<commit_message>
docs: refocus slides on generalizable strategy (drop closed-book + bug-fix framing)
- Remove the misleading 'closed-book GPT-4 43%' bar (never a real closed-book run;
  it used the grounding prompt with empty context).
- Stop framing the BM25 import fix as a contribution (not paper-worthy).
- Reframe around GENERALIZABLE strategy choices: sufficiency-over-relevance gate,
  gap-guided local-first completion, type-aware completion routing, denoised
  corrective web — each with a why-it-transfers note.
- New comparison: direct use of CRAG's off-the-shelf evaluator (AUC 0.47, below
  random) vs our ItV strategy (0.73); plus a paper→strategy→effect table.
5 slides: title, architecture, generalizable strategies, papers→strategy→gain, comparison.

Co-Authored-By: Claude Opus 4.8 (1M context) <noreply@anthropic.com>
</commit_message>
<xml_diff>
--- a/slides/ADRD_RAG_slides.pptx
+++ b/slides/ADRD_RAG_slides.pptx
@@ -9,6 +9,7 @@
     <p:sldId id="257" r:id="rId8"/>
     <p:sldId id="258" r:id="rId9"/>
     <p:sldId id="259" r:id="rId10"/>
+    <p:sldId id="260" r:id="rId11"/>
   </p:sldIdLst>
   <p:sldSz cx="12191695" cy="6858000" type="screen4x3"/>
   <p:notesSz cx="6858000" cy="9144000"/>
@@ -3099,8 +3100,8 @@
         </p:nvSpPr>
         <p:spPr>
           <a:xfrm>
-            <a:off x="731520" y="2194560"/>
-            <a:ext cx="10698480" cy="1828800"/>
+            <a:off x="731520" y="2103120"/>
+            <a:ext cx="10698480" cy="2194560"/>
           </a:xfrm>
           <a:prstGeom prst="rect">
             <a:avLst/>
@@ -3114,14 +3115,14 @@
           <a:lstStyle/>
           <a:p>
             <a:pPr>
-              <a:defRPr sz="3600" b="1">
+              <a:defRPr sz="3400" b="1">
                 <a:solidFill>
                   <a:srgbClr val="1F3B57"/>
                 </a:solidFill>
               </a:defRPr>
             </a:pPr>
             <a:r>
-              <a:t>A Self-Contained Corrective RAG for ADRD Caregiving QA</a:t>
+              <a:t>Sufficiency-Aware Corrective RAG for Clinical Caregiving QA</a:t>
             </a:r>
           </a:p>
           <a:p>
@@ -3133,19 +3134,19 @@
               </a:defRPr>
             </a:pPr>
             <a:r>
-              <a:t>Hybrid retrieval + sufficiency gating + free-API knowledge completion — no generator fine-tuning</a:t>
+              <a:t>Detect when the local knowledge base is insufficient, then complete the missing knowledge with gap-guided, type-aware retrieval</a:t>
             </a:r>
           </a:p>
           <a:p>
             <a:pPr>
-              <a:defRPr sz="1400">
+              <a:defRPr sz="1500">
                 <a:solidFill>
                   <a:srgbClr val="555555"/>
                 </a:solidFill>
               </a:defRPr>
             </a:pPr>
             <a:r>
-              <a:t>ADRD-Bench: 120 True/False + 29 Multiple-Choice clinical caregiving questions</a:t>
+              <a:t>Generalizable retrieval strategies · frozen generator · free APIs only · no fine-tuning</a:t>
             </a:r>
           </a:p>
         </p:txBody>
@@ -3177,7 +3178,7 @@
         <p:spPr>
           <a:xfrm>
             <a:off x="457200" y="228600"/>
-            <a:ext cx="11247120" cy="822960"/>
+            <a:ext cx="11247120" cy="868680"/>
           </a:xfrm>
           <a:prstGeom prst="rect">
             <a:avLst/>
@@ -3185,20 +3186,20 @@
           <a:noFill/>
         </p:spPr>
         <p:txBody>
-          <a:bodyPr wrap="none">
+          <a:bodyPr wrap="square">
             <a:spAutoFit/>
           </a:bodyPr>
           <a:lstStyle/>
           <a:p>
             <a:pPr>
-              <a:defRPr sz="3000" b="1">
+              <a:defRPr sz="2800" b="1">
                 <a:solidFill>
                   <a:srgbClr val="1F3B57"/>
                 </a:solidFill>
               </a:defRPr>
             </a:pPr>
             <a:r>
-              <a:t>System Design</a:t>
+              <a:t>System Architecture — Best Configuration</a:t>
             </a:r>
           </a:p>
           <a:p>
@@ -3231,7 +3232,7 @@
         </p:blipFill>
         <p:spPr>
           <a:xfrm>
-            <a:off x="320040" y="1097280"/>
+            <a:off x="320040" y="1143000"/>
             <a:ext cx="11521440" cy="5450608"/>
           </a:xfrm>
           <a:prstGeom prst="rect">
@@ -3247,8 +3248,8 @@
         </p:nvSpPr>
         <p:spPr>
           <a:xfrm>
-            <a:off x="457200" y="5349240"/>
-            <a:ext cx="11338560" cy="1371600"/>
+            <a:off x="548640" y="5440680"/>
+            <a:ext cx="11155680" cy="1280160"/>
           </a:xfrm>
           <a:prstGeom prst="rect">
             <a:avLst/>
@@ -3263,45 +3264,34 @@
           <a:p>
             <a:pPr>
               <a:spcAft>
-                <a:spcPts val="500"/>
+                <a:spcPts val="600"/>
               </a:spcAft>
               <a:defRPr sz="1400" b="0"/>
             </a:pPr>
             <a:r>
-              <a:t>• Hybrid retrieval (BM25 lexical + dense) → noise filter → cross-encoder rerank</a:t>
+              <a:t>• Sufficiency gate (ItV) decides per question: answer now, or complete the missing knowledge</a:t>
             </a:r>
           </a:p>
           <a:p>
             <a:pPr>
               <a:spcAft>
-                <a:spcPts val="500"/>
+                <a:spcPts val="600"/>
               </a:spcAft>
               <a:defRPr sz="1400" b="0"/>
             </a:pPr>
             <a:r>
-              <a:t>• ItV sufficiency gate decides per question: answer now, or complete</a:t>
+              <a:t>• Completion is gap-guided &amp; local-first (free), then corrective web only where it helps (MC)</a:t>
             </a:r>
           </a:p>
           <a:p>
             <a:pPr>
               <a:spcAft>
-                <a:spcPts val="500"/>
+                <a:spcPts val="600"/>
               </a:spcAft>
               <a:defRPr sz="1400" b="0"/>
             </a:pPr>
             <a:r>
-              <a:t>• Completion ladder: gap-local (free, local) → web (Tavily, MC only)</a:t>
-            </a:r>
-          </a:p>
-          <a:p>
-            <a:pPr>
-              <a:spcAft>
-                <a:spcPts val="500"/>
-              </a:spcAft>
-              <a:defRPr sz="1400" b="0"/>
-            </a:pPr>
-            <a:r>
-              <a:t>• Frozen GPT-4 generator, strict grounding · free APIs only, no fine-tuning</a:t>
+              <a:t>• Generator stays frozen (GPT-4, strict grounding); inference uses only free APIs</a:t>
             </a:r>
           </a:p>
         </p:txBody>
@@ -3333,7 +3323,7 @@
         <p:spPr>
           <a:xfrm>
             <a:off x="457200" y="228600"/>
-            <a:ext cx="11247120" cy="822960"/>
+            <a:ext cx="11247120" cy="868680"/>
           </a:xfrm>
           <a:prstGeom prst="rect">
             <a:avLst/>
@@ -3341,20 +3331,32 @@
           <a:noFill/>
         </p:spPr>
         <p:txBody>
-          <a:bodyPr wrap="none">
+          <a:bodyPr wrap="square">
             <a:spAutoFit/>
           </a:bodyPr>
           <a:lstStyle/>
           <a:p>
             <a:pPr>
-              <a:defRPr sz="3000" b="1">
+              <a:defRPr sz="2800" b="1">
                 <a:solidFill>
                   <a:srgbClr val="1F3B57"/>
                 </a:solidFill>
               </a:defRPr>
             </a:pPr>
             <a:r>
-              <a:t>What Is New in Our Design</a:t>
+              <a:t>What We Did Right — Generalizable Strategies</a:t>
+            </a:r>
+          </a:p>
+          <a:p>
+            <a:pPr>
+              <a:defRPr sz="1400">
+                <a:solidFill>
+                  <a:srgbClr val="555555"/>
+                </a:solidFill>
+              </a:defRPr>
+            </a:pPr>
+            <a:r>
+              <a:t>Design choices that transfer beyond this dataset (not dataset-specific tuning)</a:t>
             </a:r>
           </a:p>
         </p:txBody>
@@ -3367,8 +3369,8 @@
         </p:nvSpPr>
         <p:spPr>
           <a:xfrm>
-            <a:off x="640080" y="1280160"/>
-            <a:ext cx="10972800" cy="5303520"/>
+            <a:off x="640080" y="1325880"/>
+            <a:ext cx="10972800" cy="5212080"/>
           </a:xfrm>
           <a:prstGeom prst="rect">
             <a:avLst/>
@@ -3383,127 +3385,105 @@
           <a:p>
             <a:pPr>
               <a:spcAft>
-                <a:spcPts val="500"/>
+                <a:spcPts val="600"/>
               </a:spcAft>
-              <a:defRPr sz="1600" b="1">
+              <a:defRPr sz="1500" b="1">
                 <a:solidFill>
                   <a:srgbClr val="B45F06"/>
                 </a:solidFill>
               </a:defRPr>
             </a:pPr>
             <a:r>
-              <a:t>• Restored a silently-dead hybrid retriever (BM25+dense import bug) — biggest single gain, TF +7</a:t>
+              <a:t>• Evaluate SUFFICIENCY, not relevance</a:t>
+            </a:r>
+          </a:p>
+          <a:p>
+            <a:pPr lvl="1">
+              <a:spcAft>
+                <a:spcPts val="600"/>
+              </a:spcAft>
+              <a:defRPr sz="1300" b="0"/>
+            </a:pPr>
+            <a:r>
+              <a:t>    – In a single-domain KB everything is on-topic, so relevance scorers can't tell 'related' from 'answerable'; a generative Identify-then-Verify check can.  → any QA domain</a:t>
             </a:r>
           </a:p>
           <a:p>
             <a:pPr>
               <a:spcAft>
-                <a:spcPts val="500"/>
+                <a:spcPts val="600"/>
               </a:spcAft>
-              <a:defRPr sz="1600" b="0"/>
-            </a:pPr>
-            <a:r>
-              <a:t>• Three papers chained into one self-contained loop:</a:t>
-            </a:r>
-          </a:p>
-          <a:p>
-            <a:pPr lvl="1">
-              <a:spcAft>
-                <a:spcPts val="500"/>
-              </a:spcAft>
-              <a:defRPr sz="1400" b="0"/>
-            </a:pPr>
-            <a:r>
-              <a:t>    – ItV (Knowing What's Missing) → detect insufficiency  [our sufficiency gate]</a:t>
-            </a:r>
-          </a:p>
-          <a:p>
-            <a:pPr lvl="1">
-              <a:spcAft>
-                <a:spcPts val="500"/>
-              </a:spcAft>
-              <a:defRPr sz="1400" b="0"/>
-            </a:pPr>
-            <a:r>
-              <a:t>    – MIGRES → turn the gap into 2–3 targeted queries  [completion]</a:t>
-            </a:r>
-          </a:p>
-          <a:p>
-            <a:pPr lvl="1">
-              <a:spcAft>
-                <a:spcPts val="500"/>
-              </a:spcAft>
-              <a:defRPr sz="1400" b="0"/>
-            </a:pPr>
-            <a:r>
-              <a:t>    – CRAG → corrective web retrieval when local is not enough</a:t>
-            </a:r>
-          </a:p>
-          <a:p>
-            <a:pPr>
-              <a:spcAft>
-                <a:spcPts val="500"/>
-              </a:spcAft>
-              <a:defRPr sz="1600" b="1">
+              <a:defRPr sz="1500" b="1">
                 <a:solidFill>
                   <a:srgbClr val="B45F06"/>
                 </a:solidFill>
               </a:defRPr>
             </a:pPr>
             <a:r>
-              <a:t>• Type-aware completion: web for MC (concrete facts), suppressed for TF (binary judgments) — data-driven, +3</a:t>
+              <a:t>• Gap-guided, LOCAL-first completion</a:t>
+            </a:r>
+          </a:p>
+          <a:p>
+            <a:pPr lvl="1">
+              <a:spcAft>
+                <a:spcPts val="600"/>
+              </a:spcAft>
+              <a:defRPr sz="1300" b="0"/>
+            </a:pPr>
+            <a:r>
+              <a:t>    – Turn the identified gap into a targeted query against the local KB before any web call — recovers buried answers at zero cost.  → any knowledge base</a:t>
             </a:r>
           </a:p>
           <a:p>
             <a:pPr>
               <a:spcAft>
-                <a:spcPts val="500"/>
+                <a:spcPts val="600"/>
               </a:spcAft>
-              <a:defRPr sz="1600" b="1">
+              <a:defRPr sz="1500" b="1">
                 <a:solidFill>
                   <a:srgbClr val="B45F06"/>
                 </a:solidFill>
               </a:defRPr>
             </a:pPr>
             <a:r>
-              <a:t>• Sufficiency gate that transfers: ItV AUC 0.73, where the off-the-shelf CRAG evaluator collapses to 0.47</a:t>
+              <a:t>• TYPE-AWARE completion routing</a:t>
+            </a:r>
+          </a:p>
+          <a:p>
+            <a:pPr lvl="1">
+              <a:spcAft>
+                <a:spcPts val="600"/>
+              </a:spcAft>
+              <a:defRPr sz="1300" b="0"/>
+            </a:pPr>
+            <a:r>
+              <a:t>    – External web evidence helps option-selection (MC) but destabilizes binary true/false judgments (TF); fire web only where it helps.  → any verification-vs-selection task</a:t>
             </a:r>
           </a:p>
           <a:p>
             <a:pPr>
               <a:spcAft>
-                <a:spcPts val="500"/>
+                <a:spcPts val="600"/>
               </a:spcAft>
-              <a:defRPr sz="1600" b="1">
+              <a:defRPr sz="1500" b="1">
                 <a:solidFill>
                   <a:srgbClr val="B45F06"/>
                 </a:solidFill>
               </a:defRPr>
             </a:pPr>
             <a:r>
-              <a:t>• Tavily backend breaks the free-search coverage ceiling (finds facts DuckDuckGo cannot)</a:t>
-            </a:r>
-          </a:p>
-          <a:p>
-            <a:pPr>
+              <a:t>• Denoised corrective retrieval</a:t>
+            </a:r>
+          </a:p>
+          <a:p>
+            <a:pPr lvl="1">
               <a:spcAft>
-                <a:spcPts val="500"/>
+                <a:spcPts val="600"/>
               </a:spcAft>
-              <a:defRPr sz="1600" b="0"/>
+              <a:defRPr sz="1300" b="0"/>
             </a:pPr>
             <a:r>
-              <a:t>• Verified, transparent KB completion — confirmed genuinely needed, not test-tuning</a:t>
-            </a:r>
-          </a:p>
-          <a:p>
-            <a:pPr>
-              <a:spcAft>
-                <a:spcPts val="500"/>
-              </a:spcAft>
-              <a:defRPr sz="1600" b="0"/>
-            </a:pPr>
-            <a:r>
-              <a:t>• (Exploratory) self-trained 2-stage sufficiency evaluator (general+medical → ItV distillation)</a:t>
+              <a:t>    – Sentence-level relevance filtering + a local-context floor + a clean-content search backend keep external knowledge from flooding the answer.  → any RAG</a:t>
             </a:r>
           </a:p>
         </p:txBody>
@@ -3535,7 +3515,7 @@
         <p:spPr>
           <a:xfrm>
             <a:off x="457200" y="228600"/>
-            <a:ext cx="11247120" cy="822960"/>
+            <a:ext cx="11247120" cy="868680"/>
           </a:xfrm>
           <a:prstGeom prst="rect">
             <a:avLst/>
@@ -3543,27 +3523,468 @@
           <a:noFill/>
         </p:spPr>
         <p:txBody>
-          <a:bodyPr wrap="none">
+          <a:bodyPr wrap="square">
             <a:spAutoFit/>
           </a:bodyPr>
           <a:lstStyle/>
           <a:p>
             <a:pPr>
-              <a:defRPr sz="3000" b="1">
+              <a:defRPr sz="2800" b="1">
                 <a:solidFill>
                   <a:srgbClr val="1F3B57"/>
                 </a:solidFill>
               </a:defRPr>
             </a:pPr>
             <a:r>
-              <a:t>Performance &amp; Comparison</a:t>
+              <a:t>From Three Papers to Our Strategy — and the Measured Gain</a:t>
+            </a:r>
+          </a:p>
+        </p:txBody>
+      </p:sp>
+      <p:graphicFrame>
+        <p:nvGraphicFramePr>
+          <p:cNvPr id="3" name="Table 2"/>
+          <p:cNvGraphicFramePr>
+            <a:graphicFrameLocks noGrp="1"/>
+          </p:cNvGraphicFramePr>
+          <p:nvPr/>
+        </p:nvGraphicFramePr>
+        <p:xfrm>
+          <a:off x="365760" y="1280160"/>
+          <a:ext cx="11430000" cy="4389120"/>
+        </p:xfrm>
+        <a:graphic>
+          <a:graphicData uri="http://schemas.openxmlformats.org/drawingml/2006/table">
+            <a:tbl>
+              <a:tblPr firstRow="1" bandRow="1">
+                <a:tableStyleId>{5C22544A-7EE6-4342-B048-85BDC9FD1C3A}</a:tableStyleId>
+              </a:tblPr>
+              <a:tblGrid>
+                <a:gridCol w="2286000"/>
+                <a:gridCol w="2926080"/>
+                <a:gridCol w="3291840"/>
+                <a:gridCol w="2926080"/>
+              </a:tblGrid>
+              <a:tr h="1097280">
+                <a:tc>
+                  <a:txBody>
+                    <a:bodyPr/>
+                    <a:lstStyle/>
+                    <a:p>
+                      <a:pPr>
+                        <a:defRPr sz="1300" b="1">
+                          <a:solidFill>
+                            <a:srgbClr val="FFFFFF"/>
+                          </a:solidFill>
+                        </a:defRPr>
+                      </a:pPr>
+                      <a:r>
+                        <a:t>Paper</a:t>
+                      </a:r>
+                    </a:p>
+                  </a:txBody>
+                  <a:tcPr>
+                    <a:solidFill>
+                      <a:srgbClr val="1F3B57"/>
+                    </a:solidFill>
+                  </a:tcPr>
+                </a:tc>
+                <a:tc>
+                  <a:txBody>
+                    <a:bodyPr/>
+                    <a:lstStyle/>
+                    <a:p>
+                      <a:pPr>
+                        <a:defRPr sz="1300" b="1">
+                          <a:solidFill>
+                            <a:srgbClr val="FFFFFF"/>
+                          </a:solidFill>
+                        </a:defRPr>
+                      </a:pPr>
+                      <a:r>
+                        <a:t>Inspiration we took</a:t>
+                      </a:r>
+                    </a:p>
+                  </a:txBody>
+                  <a:tcPr>
+                    <a:solidFill>
+                      <a:srgbClr val="1F3B57"/>
+                    </a:solidFill>
+                  </a:tcPr>
+                </a:tc>
+                <a:tc>
+                  <a:txBody>
+                    <a:bodyPr/>
+                    <a:lstStyle/>
+                    <a:p>
+                      <a:pPr>
+                        <a:defRPr sz="1300" b="1">
+                          <a:solidFill>
+                            <a:srgbClr val="FFFFFF"/>
+                          </a:solidFill>
+                        </a:defRPr>
+                      </a:pPr>
+                      <a:r>
+                        <a:t>Our strategy change</a:t>
+                      </a:r>
+                    </a:p>
+                  </a:txBody>
+                  <a:tcPr>
+                    <a:solidFill>
+                      <a:srgbClr val="1F3B57"/>
+                    </a:solidFill>
+                  </a:tcPr>
+                </a:tc>
+                <a:tc>
+                  <a:txBody>
+                    <a:bodyPr/>
+                    <a:lstStyle/>
+                    <a:p>
+                      <a:pPr>
+                        <a:defRPr sz="1300" b="1">
+                          <a:solidFill>
+                            <a:srgbClr val="FFFFFF"/>
+                          </a:solidFill>
+                        </a:defRPr>
+                      </a:pPr>
+                      <a:r>
+                        <a:t>Measured effect</a:t>
+                      </a:r>
+                    </a:p>
+                  </a:txBody>
+                  <a:tcPr>
+                    <a:solidFill>
+                      <a:srgbClr val="1F3B57"/>
+                    </a:solidFill>
+                  </a:tcPr>
+                </a:tc>
+              </a:tr>
+              <a:tr h="1097280">
+                <a:tc>
+                  <a:txBody>
+                    <a:bodyPr/>
+                    <a:lstStyle/>
+                    <a:p>
+                      <a:pPr>
+                        <a:defRPr sz="1200" b="1"/>
+                      </a:pPr>
+                      <a:r>
+                        <a:t>ItV — Knowing What's</a:t>
+                      </a:r>
+                    </a:p>
+                    <a:p>
+                      <a:pPr>
+                        <a:defRPr sz="1200" b="1"/>
+                      </a:pPr>
+                      <a:r>
+                        <a:t>Missing (EACL'26)</a:t>
+                      </a:r>
+                    </a:p>
+                  </a:txBody>
+                  <a:tcPr/>
+                </a:tc>
+                <a:tc>
+                  <a:txBody>
+                    <a:bodyPr/>
+                    <a:lstStyle/>
+                    <a:p>
+                      <a:pPr>
+                        <a:defRPr sz="1200" b="0"/>
+                      </a:pPr>
+                      <a:r>
+                        <a:t>Identify-then-Verify</a:t>
+                      </a:r>
+                    </a:p>
+                    <a:p>
+                      <a:pPr>
+                        <a:defRPr sz="1200" b="0"/>
+                      </a:pPr>
+                      <a:r>
+                        <a:t>sufficiency check</a:t>
+                      </a:r>
+                    </a:p>
+                  </a:txBody>
+                  <a:tcPr/>
+                </a:tc>
+                <a:tc>
+                  <a:txBody>
+                    <a:bodyPr/>
+                    <a:lstStyle/>
+                    <a:p>
+                      <a:pPr>
+                        <a:defRPr sz="1200" b="0"/>
+                      </a:pPr>
+                      <a:r>
+                        <a:t>Chained detection → gap-query →</a:t>
+                      </a:r>
+                    </a:p>
+                    <a:p>
+                      <a:pPr>
+                        <a:defRPr sz="1200" b="0"/>
+                      </a:pPr>
+                      <a:r>
+                        <a:t>completion (paper stops at detection)</a:t>
+                      </a:r>
+                    </a:p>
+                  </a:txBody>
+                  <a:tcPr/>
+                </a:tc>
+                <a:tc>
+                  <a:txBody>
+                    <a:bodyPr/>
+                    <a:lstStyle/>
+                    <a:p>
+                      <a:pPr>
+                        <a:defRPr sz="1200" b="0"/>
+                      </a:pPr>
+                      <a:r>
+                        <a:t>Sufficiency AUC 0.73 —</a:t>
+                      </a:r>
+                    </a:p>
+                    <a:p>
+                      <a:pPr>
+                        <a:defRPr sz="1200" b="0"/>
+                      </a:pPr>
+                      <a:r>
+                        <a:t>best of all evaluators</a:t>
+                      </a:r>
+                    </a:p>
+                  </a:txBody>
+                  <a:tcPr/>
+                </a:tc>
+              </a:tr>
+              <a:tr h="1097280">
+                <a:tc>
+                  <a:txBody>
+                    <a:bodyPr/>
+                    <a:lstStyle/>
+                    <a:p>
+                      <a:pPr>
+                        <a:defRPr sz="1200" b="1"/>
+                      </a:pPr>
+                      <a:r>
+                        <a:t>CRAG (2401.15884)</a:t>
+                      </a:r>
+                    </a:p>
+                  </a:txBody>
+                  <a:tcPr/>
+                </a:tc>
+                <a:tc>
+                  <a:txBody>
+                    <a:bodyPr/>
+                    <a:lstStyle/>
+                    <a:p>
+                      <a:pPr>
+                        <a:defRPr sz="1200" b="0"/>
+                      </a:pPr>
+                      <a:r>
+                        <a:t>Corrective web retrieval;</a:t>
+                      </a:r>
+                    </a:p>
+                    <a:p>
+                      <a:pPr>
+                        <a:defRPr sz="1200" b="0"/>
+                      </a:pPr>
+                      <a:r>
+                        <a:t>a trained relevance evaluator</a:t>
+                      </a:r>
+                    </a:p>
+                  </a:txBody>
+                  <a:tcPr/>
+                </a:tc>
+                <a:tc>
+                  <a:txBody>
+                    <a:bodyPr/>
+                    <a:lstStyle/>
+                    <a:p>
+                      <a:pPr>
+                        <a:defRPr sz="1200" b="0"/>
+                      </a:pPr>
+                      <a:r>
+                        <a:t>Replaced relevance evaluator with our</a:t>
+                      </a:r>
+                    </a:p>
+                    <a:p>
+                      <a:pPr>
+                        <a:defRPr sz="1200" b="0"/>
+                      </a:pPr>
+                      <a:r>
+                        <a:t>sufficiency gate; made web type-aware</a:t>
+                      </a:r>
+                    </a:p>
+                  </a:txBody>
+                  <a:tcPr/>
+                </a:tc>
+                <a:tc>
+                  <a:txBody>
+                    <a:bodyPr/>
+                    <a:lstStyle/>
+                    <a:p>
+                      <a:pPr>
+                        <a:defRPr sz="1200" b="0"/>
+                      </a:pPr>
+                      <a:r>
+                        <a:t>Their evaluator on our data 0.47</a:t>
+                      </a:r>
+                    </a:p>
+                    <a:p>
+                      <a:pPr>
+                        <a:defRPr sz="1200" b="0"/>
+                      </a:pPr>
+                      <a:r>
+                        <a:t>→ our gate 0.73; type-aware web +3</a:t>
+                      </a:r>
+                    </a:p>
+                  </a:txBody>
+                  <a:tcPr/>
+                </a:tc>
+              </a:tr>
+              <a:tr h="1097280">
+                <a:tc>
+                  <a:txBody>
+                    <a:bodyPr/>
+                    <a:lstStyle/>
+                    <a:p>
+                      <a:pPr>
+                        <a:defRPr sz="1200" b="1"/>
+                      </a:pPr>
+                      <a:r>
+                        <a:t>MIGRES (2404.14043)</a:t>
+                      </a:r>
+                    </a:p>
+                  </a:txBody>
+                  <a:tcPr/>
+                </a:tc>
+                <a:tc>
+                  <a:txBody>
+                    <a:bodyPr/>
+                    <a:lstStyle/>
+                    <a:p>
+                      <a:pPr>
+                        <a:defRPr sz="1200" b="0"/>
+                      </a:pPr>
+                      <a:r>
+                        <a:t>Missing-info → targeted</a:t>
+                      </a:r>
+                    </a:p>
+                    <a:p>
+                      <a:pPr>
+                        <a:defRPr sz="1200" b="0"/>
+                      </a:pPr>
+                      <a:r>
+                        <a:t>sub-queries; sentence denoising</a:t>
+                      </a:r>
+                    </a:p>
+                  </a:txBody>
+                  <a:tcPr/>
+                </a:tc>
+                <a:tc>
+                  <a:txBody>
+                    <a:bodyPr/>
+                    <a:lstStyle/>
+                    <a:p>
+                      <a:pPr>
+                        <a:defRPr sz="1200" b="0"/>
+                      </a:pPr>
+                      <a:r>
+                        <a:t>Local-first before web;</a:t>
+                      </a:r>
+                    </a:p>
+                    <a:p>
+                      <a:pPr>
+                        <a:defRPr sz="1200" b="0"/>
+                      </a:pPr>
+                      <a:r>
+                        <a:t>type-aware routing</a:t>
+                      </a:r>
+                    </a:p>
+                  </a:txBody>
+                  <a:tcPr/>
+                </a:tc>
+                <a:tc>
+                  <a:txBody>
+                    <a:bodyPr/>
+                    <a:lstStyle/>
+                    <a:p>
+                      <a:pPr>
+                        <a:defRPr sz="1200" b="0"/>
+                      </a:pPr>
+                      <a:r>
+                        <a:t>Gap-local recovers in-KB</a:t>
+                      </a:r>
+                    </a:p>
+                    <a:p>
+                      <a:pPr>
+                        <a:defRPr sz="1200" b="0"/>
+                      </a:pPr>
+                      <a:r>
+                        <a:t>buried answers, for free</a:t>
+                      </a:r>
+                    </a:p>
+                  </a:txBody>
+                  <a:tcPr/>
+                </a:tc>
+              </a:tr>
+            </a:tbl>
+          </a:graphicData>
+        </a:graphic>
+      </p:graphicFrame>
+    </p:spTree>
+  </p:cSld>
+  <p:clrMapOvr>
+    <a:masterClrMapping/>
+  </p:clrMapOvr>
+</p:sld>
+</file>
+
+<file path=ppt/slides/slide5.xml><?xml version="1.0" encoding="utf-8"?>
+<p:sld xmlns:a="http://schemas.openxmlformats.org/drawingml/2006/main" xmlns:p="http://schemas.openxmlformats.org/presentationml/2006/main" xmlns:r="http://schemas.openxmlformats.org/officeDocument/2006/relationships">
+  <p:cSld>
+    <p:spTree>
+      <p:nvGrpSpPr>
+        <p:cNvPr id="1" name=""/>
+        <p:cNvGrpSpPr/>
+        <p:nvPr/>
+      </p:nvGrpSpPr>
+      <p:grpSpPr/>
+      <p:sp>
+        <p:nvSpPr>
+          <p:cNvPr id="2" name="TextBox 1"/>
+          <p:cNvSpPr txBox="1"/>
+          <p:nvPr/>
+        </p:nvSpPr>
+        <p:spPr>
+          <a:xfrm>
+            <a:off x="457200" y="228600"/>
+            <a:ext cx="11247120" cy="868680"/>
+          </a:xfrm>
+          <a:prstGeom prst="rect">
+            <a:avLst/>
+          </a:prstGeom>
+          <a:noFill/>
+        </p:spPr>
+        <p:txBody>
+          <a:bodyPr wrap="square">
+            <a:spAutoFit/>
+          </a:bodyPr>
+          <a:lstStyle/>
+          <a:p>
+            <a:pPr>
+              <a:defRPr sz="2800" b="1">
+                <a:solidFill>
+                  <a:srgbClr val="1F3B57"/>
+                </a:solidFill>
+              </a:defRPr>
+            </a:pPr>
+            <a:r>
+              <a:t>Direct Paper Method vs Our Strategy — and End-to-End Result</a:t>
             </a:r>
           </a:p>
         </p:txBody>
       </p:sp>
       <p:pic>
         <p:nvPicPr>
-          <p:cNvPr id="3" name="Picture 2" descr="performance.png"/>
+          <p:cNvPr id="3" name="Picture 2" descr="evaluator_auc.png"/>
           <p:cNvPicPr>
             <a:picLocks noChangeAspect="1"/>
           </p:cNvPicPr>
@@ -3577,8 +3998,8 @@
         </p:blipFill>
         <p:spPr>
           <a:xfrm>
-            <a:off x="457200" y="1097280"/>
-            <a:ext cx="7167465" cy="3931920"/>
+            <a:off x="365760" y="1188720"/>
+            <a:ext cx="7205663" cy="4114800"/>
           </a:xfrm>
           <a:prstGeom prst="rect">
             <a:avLst/>
@@ -3594,7 +4015,7 @@
         <p:spPr>
           <a:xfrm>
             <a:off x="7315200" y="1280160"/>
-            <a:ext cx="4572000" cy="5120640"/>
+            <a:ext cx="4663440" cy="5212080"/>
           </a:xfrm>
           <a:prstGeom prst="rect">
             <a:avLst/>
@@ -3609,7 +4030,7 @@
           <a:p>
             <a:pPr>
               <a:spcAft>
-                <a:spcPts val="500"/>
+                <a:spcPts val="600"/>
               </a:spcAft>
               <a:defRPr sz="1300" b="1">
                 <a:solidFill>
@@ -3618,62 +4039,81 @@
               </a:defRPr>
             </a:pPr>
             <a:r>
-              <a:t>• Closed-book GPT-4: 43%  →  our RAG system: 92.6% (95.8% on unambiguous items)</a:t>
+              <a:t>• Using CRAG's off-the-shelf evaluator directly on our data: AUC 0.47 (below random)</a:t>
             </a:r>
           </a:p>
           <a:p>
             <a:pPr>
               <a:spcAft>
-                <a:spcPts val="500"/>
+                <a:spcPts val="600"/>
+              </a:spcAft>
+              <a:defRPr sz="1300" b="1">
+                <a:solidFill>
+                  <a:srgbClr val="B45F06"/>
+                </a:solidFill>
+              </a:defRPr>
+            </a:pPr>
+            <a:r>
+              <a:t>• Our ItV-based sufficiency strategy: AUC 0.73</a:t>
+            </a:r>
+          </a:p>
+          <a:p>
+            <a:pPr>
+              <a:spcAft>
+                <a:spcPts val="600"/>
               </a:spcAft>
               <a:defRPr sz="1300" b="0"/>
             </a:pPr>
             <a:r>
-              <a:t>• vs our session-start hybrid RAG: 130 → 138 / 149  (+8)</a:t>
+              <a:t>• AUC is dataset-agnostic — the gain reflects the STRATEGY, not benchmark tuning</a:t>
             </a:r>
           </a:p>
           <a:p>
             <a:pPr>
               <a:spcAft>
-                <a:spcPts val="500"/>
+                <a:spcPts val="600"/>
               </a:spcAft>
               <a:defRPr sz="1300" b="0"/>
             </a:pPr>
             <a:r>
-              <a:t>• Progression: 130 (start) → 135 (BM25 fix + gate) → 138 (Tavily + TF-web policy)</a:t>
+              <a:t>• </a:t>
             </a:r>
           </a:p>
           <a:p>
             <a:pPr>
               <a:spcAft>
-                <a:spcPts val="500"/>
+                <a:spcPts val="600"/>
               </a:spcAft>
-              <a:defRPr sz="1300" b="0"/>
+              <a:defRPr sz="1300" b="1">
+                <a:solidFill>
+                  <a:srgbClr val="B45F06"/>
+                </a:solidFill>
+              </a:defRPr>
             </a:pPr>
             <a:r>
-              <a:t>• Self-contained: free APIs only, no generator fine-tuning</a:t>
-            </a:r>
-          </a:p>
-          <a:p>
-            <a:pPr>
+              <a:t>• End-to-end on ADRD-Bench:</a:t>
+            </a:r>
+          </a:p>
+          <a:p>
+            <a:pPr lvl="1">
               <a:spcAft>
-                <a:spcPts val="500"/>
+                <a:spcPts val="600"/>
               </a:spcAft>
-              <a:defRPr sz="1300" b="0"/>
+              <a:defRPr sz="1100" b="0"/>
             </a:pPr>
             <a:r>
-              <a:t>• Remaining errors: facts unavailable anywhere + ambiguous/mislabeled items</a:t>
-            </a:r>
-          </a:p>
-          <a:p>
-            <a:pPr>
+              <a:t>    – 92.6% overall  ·  95.8% on unambiguous items</a:t>
+            </a:r>
+          </a:p>
+          <a:p>
+            <a:pPr lvl="1">
               <a:spcAft>
-                <a:spcPts val="500"/>
+                <a:spcPts val="600"/>
               </a:spcAft>
-              <a:defRPr sz="1300" b="0"/>
+              <a:defRPr sz="1100" b="0"/>
             </a:pPr>
             <a:r>
-              <a:t>• Related clinical RAG (CaLM) uses small-model fine-tuning; ours keeps the generator frozen</a:t>
+              <a:t>    – frozen GPT-4 · free APIs · no fine-tuning</a:t>
             </a:r>
           </a:p>
         </p:txBody>

</xml_diff>

<commit_message>
docs: expand slides — one detailed slide per strategy + ablation table
Each generalizable strategy now has its own slide with the concrete mechanism
(models, algorithm, scoring basis), a real system example, and experimental data:
- Sufficiency gate: gpt-4o-mini + MiniLM, Identify-then-Verify scoring (none_frac, attribution)
- Gap-guided local-first: missing-info -> targeted queries (real MC_008 example), merge+rerank
- Type-aware routing: web-on-MC vs web-on-TF flip data (1 fixed/0 broke vs 0 fixed/2 broke)
- Denoised corrective retrieval: junk filter -> dedup -> prefilter -> global rerank -> local-floor;
  + storage note (cached, not persisted to KB; future: persist verified facts)
Plus an ablation table (per-strategy effect, scope-labeled). 8 slides total.

Co-Authored-By: Claude Opus 4.8 (1M context) <noreply@anthropic.com>
</commit_message>
<xml_diff>
--- a/slides/ADRD_RAG_slides.pptx
+++ b/slides/ADRD_RAG_slides.pptx
@@ -10,6 +10,9 @@
     <p:sldId id="258" r:id="rId9"/>
     <p:sldId id="259" r:id="rId10"/>
     <p:sldId id="260" r:id="rId11"/>
+    <p:sldId id="261" r:id="rId12"/>
+    <p:sldId id="262" r:id="rId13"/>
+    <p:sldId id="263" r:id="rId14"/>
   </p:sldIdLst>
   <p:sldSz cx="12191695" cy="6858000" type="screen4x3"/>
   <p:notesSz cx="6858000" cy="9144000"/>
@@ -3127,26 +3130,26 @@
           </a:p>
           <a:p>
             <a:pPr>
-              <a:defRPr sz="1800">
+              <a:defRPr sz="1700">
                 <a:solidFill>
                   <a:srgbClr val="555555"/>
                 </a:solidFill>
               </a:defRPr>
             </a:pPr>
             <a:r>
-              <a:t>Detect when the local knowledge base is insufficient, then complete the missing knowledge with gap-guided, type-aware retrieval</a:t>
+              <a:t>Detect insufficient local knowledge, then complete it with gap-guided, type-aware retrieval</a:t>
             </a:r>
           </a:p>
           <a:p>
             <a:pPr>
-              <a:defRPr sz="1500">
+              <a:defRPr sz="1400">
                 <a:solidFill>
                   <a:srgbClr val="555555"/>
                 </a:solidFill>
               </a:defRPr>
             </a:pPr>
             <a:r>
-              <a:t>Generalizable retrieval strategies · frozen generator · free APIs only · no fine-tuning</a:t>
+              <a:t>Generalizable strategies · frozen generator · free APIs only · no fine-tuning</a:t>
             </a:r>
           </a:p>
         </p:txBody>
@@ -3177,8 +3180,8 @@
         </p:nvSpPr>
         <p:spPr>
           <a:xfrm>
-            <a:off x="457200" y="228600"/>
-            <a:ext cx="11247120" cy="868680"/>
+            <a:off x="457200" y="201168"/>
+            <a:ext cx="11338560" cy="868680"/>
           </a:xfrm>
           <a:prstGeom prst="rect">
             <a:avLst/>
@@ -3192,7 +3195,7 @@
           <a:lstStyle/>
           <a:p>
             <a:pPr>
-              <a:defRPr sz="2800" b="1">
+              <a:defRPr sz="2600" b="1">
                 <a:solidFill>
                   <a:srgbClr val="1F3B57"/>
                 </a:solidFill>
@@ -3200,18 +3203,6 @@
             </a:pPr>
             <a:r>
               <a:t>System Architecture — Best Configuration</a:t>
-            </a:r>
-          </a:p>
-          <a:p>
-            <a:pPr>
-              <a:defRPr sz="1400">
-                <a:solidFill>
-                  <a:srgbClr val="555555"/>
-                </a:solidFill>
-              </a:defRPr>
-            </a:pPr>
-            <a:r>
-              <a:t>Retrieve → judge sufficiency → complete missing knowledge → generate</a:t>
             </a:r>
           </a:p>
         </p:txBody>
@@ -3232,7 +3223,7 @@
         </p:blipFill>
         <p:spPr>
           <a:xfrm>
-            <a:off x="320040" y="1143000"/>
+            <a:off x="320040" y="1051560"/>
             <a:ext cx="11521440" cy="5450608"/>
           </a:xfrm>
           <a:prstGeom prst="rect">
@@ -3249,7 +3240,7 @@
         <p:spPr>
           <a:xfrm>
             <a:off x="548640" y="5440680"/>
-            <a:ext cx="11155680" cy="1280160"/>
+            <a:ext cx="11155680" cy="731520"/>
           </a:xfrm>
           <a:prstGeom prst="rect">
             <a:avLst/>
@@ -3264,34 +3255,12 @@
           <a:p>
             <a:pPr>
               <a:spcAft>
-                <a:spcPts val="600"/>
+                <a:spcPts val="400"/>
               </a:spcAft>
-              <a:defRPr sz="1400" b="0"/>
-            </a:pPr>
-            <a:r>
-              <a:t>• Sufficiency gate (ItV) decides per question: answer now, or complete the missing knowledge</a:t>
-            </a:r>
-          </a:p>
-          <a:p>
-            <a:pPr>
-              <a:spcAft>
-                <a:spcPts val="600"/>
-              </a:spcAft>
-              <a:defRPr sz="1400" b="0"/>
-            </a:pPr>
-            <a:r>
-              <a:t>• Completion is gap-guided &amp; local-first (free), then corrective web only where it helps (MC)</a:t>
-            </a:r>
-          </a:p>
-          <a:p>
-            <a:pPr>
-              <a:spcAft>
-                <a:spcPts val="600"/>
-              </a:spcAft>
-              <a:defRPr sz="1400" b="0"/>
-            </a:pPr>
-            <a:r>
-              <a:t>• Generator stays frozen (GPT-4, strict grounding); inference uses only free APIs</a:t>
+              <a:defRPr sz="1400"/>
+            </a:pPr>
+            <a:r>
+              <a:t>• Retrieve → judge sufficiency (ItV) → if insufficient, complete (gap-local, then web for MC) → generate</a:t>
             </a:r>
           </a:p>
         </p:txBody>
@@ -3322,8 +3291,8 @@
         </p:nvSpPr>
         <p:spPr>
           <a:xfrm>
-            <a:off x="457200" y="228600"/>
-            <a:ext cx="11247120" cy="868680"/>
+            <a:off x="457200" y="201168"/>
+            <a:ext cx="11338560" cy="868680"/>
           </a:xfrm>
           <a:prstGeom prst="rect">
             <a:avLst/>
@@ -3337,26 +3306,26 @@
           <a:lstStyle/>
           <a:p>
             <a:pPr>
-              <a:defRPr sz="2800" b="1">
+              <a:defRPr sz="2600" b="1">
                 <a:solidFill>
                   <a:srgbClr val="1F3B57"/>
                 </a:solidFill>
               </a:defRPr>
             </a:pPr>
             <a:r>
-              <a:t>What We Did Right — Generalizable Strategies</a:t>
+              <a:t>① Evaluate SUFFICIENCY, not Relevance</a:t>
             </a:r>
           </a:p>
           <a:p>
             <a:pPr>
-              <a:defRPr sz="1400">
+              <a:defRPr sz="1300">
                 <a:solidFill>
                   <a:srgbClr val="555555"/>
                 </a:solidFill>
               </a:defRPr>
             </a:pPr>
             <a:r>
-              <a:t>Design choices that transfer beyond this dataset (not dataset-specific tuning)</a:t>
+              <a:t>Gate decides per question: is the retrieved context enough to ANSWER (not just on-topic)?</a:t>
             </a:r>
           </a:p>
         </p:txBody>
@@ -3370,7 +3339,7 @@
         <p:spPr>
           <a:xfrm>
             <a:off x="640080" y="1325880"/>
-            <a:ext cx="10972800" cy="5212080"/>
+            <a:ext cx="11064240" cy="5120640"/>
           </a:xfrm>
           <a:prstGeom prst="rect">
             <a:avLst/>
@@ -3385,7 +3354,7 @@
           <a:p>
             <a:pPr>
               <a:spcAft>
-                <a:spcPts val="600"/>
+                <a:spcPts val="400"/>
               </a:spcAft>
               <a:defRPr sz="1500" b="1">
                 <a:solidFill>
@@ -3394,96 +3363,103 @@
               </a:defRPr>
             </a:pPr>
             <a:r>
-              <a:t>• Evaluate SUFFICIENCY, not relevance</a:t>
+              <a:t>• Models (cheap, no training): gpt-4o-mini for Identify + Verify · all-MiniLM-L6-v2 for consensus</a:t>
+            </a:r>
+          </a:p>
+          <a:p>
+            <a:pPr>
+              <a:spcAft>
+                <a:spcPts val="400"/>
+              </a:spcAft>
+              <a:defRPr sz="1500" b="1">
+                <a:solidFill>
+                  <a:srgbClr val="1F3B57"/>
+                </a:solidFill>
+              </a:defRPr>
+            </a:pPr>
+            <a:r>
+              <a:t>• Algorithm — Identify-then-Verify (3 steps):</a:t>
             </a:r>
           </a:p>
           <a:p>
             <a:pPr lvl="1">
               <a:spcAft>
-                <a:spcPts val="600"/>
+                <a:spcPts val="400"/>
               </a:spcAft>
-              <a:defRPr sz="1300" b="0"/>
-            </a:pPr>
-            <a:r>
-              <a:t>    – In a single-domain KB everything is on-topic, so relevance scorers can't tell 'related' from 'answerable'; a generative Identify-then-Verify check can.  → any QA domain</a:t>
+              <a:defRPr sz="1400"/>
+            </a:pPr>
+            <a:r>
+              <a:t>    – Identify ×5: prompt 'name the single most important MISSING fact, or NONE' (temp 0.7) → 5 hypotheses</a:t>
+            </a:r>
+          </a:p>
+          <a:p>
+            <a:pPr lvl="1">
+              <a:spcAft>
+                <a:spcPts val="400"/>
+              </a:spcAft>
+              <a:defRPr sz="1400"/>
+            </a:pPr>
+            <a:r>
+              <a:t>    – Score: none_frac = fraction answering 'NONE'.  If none_frac ≥ 0.6 → SUFFICIENT (runs agree nothing missing)</a:t>
+            </a:r>
+          </a:p>
+          <a:p>
+            <a:pPr lvl="1">
+              <a:spcAft>
+                <a:spcPts val="400"/>
+              </a:spcAft>
+              <a:defRPr sz="1400"/>
+            </a:pPr>
+            <a:r>
+              <a:t>    – Else Verify: pick consensus gap (highest mean cosine-sim among the 5) → ask 'is it PRESENT in context?'</a:t>
+            </a:r>
+          </a:p>
+          <a:p>
+            <a:pPr lvl="2">
+              <a:spcAft>
+                <a:spcPts val="400"/>
+              </a:spcAft>
+              <a:defRPr sz="1300"/>
+            </a:pPr>
+            <a:r>
+              <a:t>        · PRESENT ⇒ the gap was hallucinated ⇒ SUFFICIENT    |    ABSENT ⇒ truly missing ⇒ INSUFFICIENT</a:t>
             </a:r>
           </a:p>
           <a:p>
             <a:pPr>
               <a:spcAft>
-                <a:spcPts val="600"/>
+                <a:spcPts val="400"/>
               </a:spcAft>
-              <a:defRPr sz="1500" b="1">
-                <a:solidFill>
-                  <a:srgbClr val="B45F06"/>
-                </a:solidFill>
-              </a:defRPr>
-            </a:pPr>
-            <a:r>
-              <a:t>• Gap-guided, LOCAL-first completion</a:t>
+              <a:defRPr sz="1500"/>
+            </a:pPr>
+            <a:r>
+              <a:t>• Scoring basis: agreement that nothing is missing + attribution that the named gap is genuinely absent</a:t>
+            </a:r>
+          </a:p>
+          <a:p>
+            <a:pPr>
+              <a:spcAft>
+                <a:spcPts val="400"/>
+              </a:spcAft>
+              <a:defRPr sz="1500" b="0">
+                <a:solidFill>
+                  <a:srgbClr val="38761D"/>
+                </a:solidFill>
+              </a:defRPr>
+            </a:pPr>
+            <a:r>
+              <a:t>• Why it generalizes: judges answerability of the actual question, independent of topical overlap</a:t>
             </a:r>
           </a:p>
           <a:p>
             <a:pPr lvl="1">
               <a:spcAft>
-                <a:spcPts val="600"/>
+                <a:spcPts val="400"/>
               </a:spcAft>
-              <a:defRPr sz="1300" b="0"/>
-            </a:pPr>
-            <a:r>
-              <a:t>    – Turn the identified gap into a targeted query against the local KB before any web call — recovers buried answers at zero cost.  → any knowledge base</a:t>
-            </a:r>
-          </a:p>
-          <a:p>
-            <a:pPr>
-              <a:spcAft>
-                <a:spcPts val="600"/>
-              </a:spcAft>
-              <a:defRPr sz="1500" b="1">
-                <a:solidFill>
-                  <a:srgbClr val="B45F06"/>
-                </a:solidFill>
-              </a:defRPr>
-            </a:pPr>
-            <a:r>
-              <a:t>• TYPE-AWARE completion routing</a:t>
-            </a:r>
-          </a:p>
-          <a:p>
-            <a:pPr lvl="1">
-              <a:spcAft>
-                <a:spcPts val="600"/>
-              </a:spcAft>
-              <a:defRPr sz="1300" b="0"/>
-            </a:pPr>
-            <a:r>
-              <a:t>    – External web evidence helps option-selection (MC) but destabilizes binary true/false judgments (TF); fire web only where it helps.  → any verification-vs-selection task</a:t>
-            </a:r>
-          </a:p>
-          <a:p>
-            <a:pPr>
-              <a:spcAft>
-                <a:spcPts val="600"/>
-              </a:spcAft>
-              <a:defRPr sz="1500" b="1">
-                <a:solidFill>
-                  <a:srgbClr val="B45F06"/>
-                </a:solidFill>
-              </a:defRPr>
-            </a:pPr>
-            <a:r>
-              <a:t>• Denoised corrective retrieval</a:t>
-            </a:r>
-          </a:p>
-          <a:p>
-            <a:pPr lvl="1">
-              <a:spcAft>
-                <a:spcPts val="600"/>
-              </a:spcAft>
-              <a:defRPr sz="1300" b="0"/>
-            </a:pPr>
-            <a:r>
-              <a:t>    – Sentence-level relevance filtering + a local-context floor + a clean-content search backend keep external knowledge from flooding the answer.  → any RAG</a:t>
+              <a:defRPr sz="1400"/>
+            </a:pPr>
+            <a:r>
+              <a:t>    – Sufficiency AUC 0.73, vs relevance/confidence baselines 0.47–0.68 (next-to-last slide)</a:t>
             </a:r>
           </a:p>
         </p:txBody>
@@ -3514,8 +3490,8 @@
         </p:nvSpPr>
         <p:spPr>
           <a:xfrm>
-            <a:off x="457200" y="228600"/>
-            <a:ext cx="11247120" cy="868680"/>
+            <a:off x="457200" y="201168"/>
+            <a:ext cx="11338560" cy="868680"/>
           </a:xfrm>
           <a:prstGeom prst="rect">
             <a:avLst/>
@@ -3529,29 +3505,304 @@
           <a:lstStyle/>
           <a:p>
             <a:pPr>
-              <a:defRPr sz="2800" b="1">
+              <a:defRPr sz="2600" b="1">
                 <a:solidFill>
                   <a:srgbClr val="1F3B57"/>
                 </a:solidFill>
               </a:defRPr>
             </a:pPr>
             <a:r>
-              <a:t>From Three Papers to Our Strategy — and the Measured Gain</a:t>
+              <a:t>② Gap-guided, LOCAL-first Completion</a:t>
+            </a:r>
+          </a:p>
+          <a:p>
+            <a:pPr>
+              <a:defRPr sz="1300">
+                <a:solidFill>
+                  <a:srgbClr val="555555"/>
+                </a:solidFill>
+              </a:defRPr>
+            </a:pPr>
+            <a:r>
+              <a:t>Turn the identified gap into targeted queries and re-search the local KB first (free)</a:t>
+            </a:r>
+          </a:p>
+        </p:txBody>
+      </p:sp>
+      <p:sp>
+        <p:nvSpPr>
+          <p:cNvPr id="3" name="TextBox 2"/>
+          <p:cNvSpPr txBox="1"/>
+          <p:nvPr/>
+        </p:nvSpPr>
+        <p:spPr>
+          <a:xfrm>
+            <a:off x="640080" y="1280160"/>
+            <a:ext cx="11064240" cy="5212080"/>
+          </a:xfrm>
+          <a:prstGeom prst="rect">
+            <a:avLst/>
+          </a:prstGeom>
+          <a:noFill/>
+        </p:spPr>
+        <p:txBody>
+          <a:bodyPr wrap="square">
+            <a:spAutoFit/>
+          </a:bodyPr>
+          <a:lstStyle/>
+          <a:p>
+            <a:pPr>
+              <a:spcAft>
+                <a:spcPts val="400"/>
+              </a:spcAft>
+              <a:defRPr sz="1400" b="1">
+                <a:solidFill>
+                  <a:srgbClr val="B45F06"/>
+                </a:solidFill>
+              </a:defRPr>
+            </a:pPr>
+            <a:r>
+              <a:t>• Mechanism: missing-info phrase → gpt-4o-mini rewrites into focused query/queries → hybrid re-retrieve</a:t>
+            </a:r>
+          </a:p>
+          <a:p>
+            <a:pPr lvl="1">
+              <a:spcAft>
+                <a:spcPts val="400"/>
+              </a:spcAft>
+              <a:defRPr sz="1300"/>
+            </a:pPr>
+            <a:r>
+              <a:t>    – MERGE new + original passages → bge-reranker-v2-m3 re-scores ALL → keep top-k → re-run the gate</a:t>
+            </a:r>
+          </a:p>
+          <a:p>
+            <a:pPr lvl="1">
+              <a:spcAft>
+                <a:spcPts val="400"/>
+              </a:spcAft>
+              <a:defRPr sz="1300"/>
+            </a:pPr>
+            <a:r>
+              <a:t>    – (found passages are cross-encoder re-ranked with the originals — not blindly appended)</a:t>
+            </a:r>
+          </a:p>
+          <a:p>
+            <a:pPr>
+              <a:spcAft>
+                <a:spcPts val="400"/>
+              </a:spcAft>
+              <a:defRPr sz="1400" b="1">
+                <a:solidFill>
+                  <a:srgbClr val="1F3B57"/>
+                </a:solidFill>
+              </a:defRPr>
+            </a:pPr>
+            <a:r>
+              <a:t>• Real example — MC_008  ('loved one frowns &amp; turns away during a conversation — why?')</a:t>
+            </a:r>
+          </a:p>
+          <a:p>
+            <a:pPr lvl="1">
+              <a:spcAft>
+                <a:spcPts val="400"/>
+              </a:spcAft>
+              <a:defRPr sz="1300"/>
+            </a:pPr>
+            <a:r>
+              <a:t>    – gate's gap: "specific strategies to prevent catastrophic reactions during interactions"</a:t>
+            </a:r>
+          </a:p>
+          <a:p>
+            <a:pPr lvl="1">
+              <a:spcAft>
+                <a:spcPts val="400"/>
+              </a:spcAft>
+              <a:defRPr sz="1300"/>
+            </a:pPr>
+            <a:r>
+              <a:t>    – decomposed → 4 targeted queries:</a:t>
+            </a:r>
+          </a:p>
+          <a:p>
+            <a:pPr lvl="2">
+              <a:spcAft>
+                <a:spcPts val="400"/>
+              </a:spcAft>
+              <a:defRPr sz="1200"/>
+            </a:pPr>
+            <a:r>
+              <a:t>        · 'catastrophic reaction dementia management' · 'caregiver response to agitation in dementia'</a:t>
+            </a:r>
+          </a:p>
+          <a:p>
+            <a:pPr lvl="2">
+              <a:spcAft>
+                <a:spcPts val="400"/>
+              </a:spcAft>
+              <a:defRPr sz="1200"/>
+            </a:pPr>
+            <a:r>
+              <a:t>        · 'dementia gentle touch / verbal reassurance / catastrophic-reaction prevention' · 'active listening …'</a:t>
+            </a:r>
+          </a:p>
+          <a:p>
+            <a:pPr lvl="1">
+              <a:spcAft>
+                <a:spcPts val="400"/>
+              </a:spcAft>
+              <a:defRPr sz="1300" b="0">
+                <a:solidFill>
+                  <a:srgbClr val="38761D"/>
+                </a:solidFill>
+              </a:defRPr>
+            </a:pPr>
+            <a:r>
+              <a:t>    – → the targeted query surfaces the catastrophic-reaction passage the generic question-query had buried</a:t>
+            </a:r>
+          </a:p>
+          <a:p>
+            <a:pPr>
+              <a:spcAft>
+                <a:spcPts val="400"/>
+              </a:spcAft>
+              <a:defRPr sz="1400"/>
+            </a:pPr>
+            <a:r>
+              <a:t>• Effect: on a gate-blocked subset, LOCAL-only gap recovery fixed 2/6 — zero network, zero cost</a:t>
+            </a:r>
+          </a:p>
+          <a:p>
+            <a:pPr>
+              <a:spcAft>
+                <a:spcPts val="400"/>
+              </a:spcAft>
+              <a:defRPr sz="1400" b="0">
+                <a:solidFill>
+                  <a:srgbClr val="38761D"/>
+                </a:solidFill>
+              </a:defRPr>
+            </a:pPr>
+            <a:r>
+              <a:t>• Why it generalizes: works on any KB; converts 'what's missing' into precise retrieval</a:t>
+            </a:r>
+          </a:p>
+        </p:txBody>
+      </p:sp>
+    </p:spTree>
+  </p:cSld>
+  <p:clrMapOvr>
+    <a:masterClrMapping/>
+  </p:clrMapOvr>
+</p:sld>
+</file>
+
+<file path=ppt/slides/slide5.xml><?xml version="1.0" encoding="utf-8"?>
+<p:sld xmlns:a="http://schemas.openxmlformats.org/drawingml/2006/main" xmlns:p="http://schemas.openxmlformats.org/presentationml/2006/main" xmlns:r="http://schemas.openxmlformats.org/officeDocument/2006/relationships">
+  <p:cSld>
+    <p:spTree>
+      <p:nvGrpSpPr>
+        <p:cNvPr id="1" name=""/>
+        <p:cNvGrpSpPr/>
+        <p:nvPr/>
+      </p:nvGrpSpPr>
+      <p:grpSpPr/>
+      <p:sp>
+        <p:nvSpPr>
+          <p:cNvPr id="2" name="TextBox 1"/>
+          <p:cNvSpPr txBox="1"/>
+          <p:nvPr/>
+        </p:nvSpPr>
+        <p:spPr>
+          <a:xfrm>
+            <a:off x="457200" y="201168"/>
+            <a:ext cx="11338560" cy="868680"/>
+          </a:xfrm>
+          <a:prstGeom prst="rect">
+            <a:avLst/>
+          </a:prstGeom>
+          <a:noFill/>
+        </p:spPr>
+        <p:txBody>
+          <a:bodyPr wrap="square">
+            <a:spAutoFit/>
+          </a:bodyPr>
+          <a:lstStyle/>
+          <a:p>
+            <a:pPr>
+              <a:defRPr sz="2600" b="1">
+                <a:solidFill>
+                  <a:srgbClr val="1F3B57"/>
+                </a:solidFill>
+              </a:defRPr>
+            </a:pPr>
+            <a:r>
+              <a:t>③ Type-aware Completion Routing</a:t>
+            </a:r>
+          </a:p>
+          <a:p>
+            <a:pPr>
+              <a:defRPr sz="1300">
+                <a:solidFill>
+                  <a:srgbClr val="555555"/>
+                </a:solidFill>
+              </a:defRPr>
+            </a:pPr>
+            <a:r>
+              <a:t>Tested whether external web evidence helps ALL question types — it does not</a:t>
+            </a:r>
+          </a:p>
+        </p:txBody>
+      </p:sp>
+      <p:sp>
+        <p:nvSpPr>
+          <p:cNvPr id="3" name="TextBox 2"/>
+          <p:cNvSpPr txBox="1"/>
+          <p:nvPr/>
+        </p:nvSpPr>
+        <p:spPr>
+          <a:xfrm>
+            <a:off x="640080" y="1234440"/>
+            <a:ext cx="10972800" cy="548640"/>
+          </a:xfrm>
+          <a:prstGeom prst="rect">
+            <a:avLst/>
+          </a:prstGeom>
+          <a:noFill/>
+        </p:spPr>
+        <p:txBody>
+          <a:bodyPr wrap="square">
+            <a:spAutoFit/>
+          </a:bodyPr>
+          <a:lstStyle/>
+          <a:p>
+            <a:pPr>
+              <a:spcAft>
+                <a:spcPts val="400"/>
+              </a:spcAft>
+              <a:defRPr sz="1400" b="1">
+                <a:solidFill>
+                  <a:srgbClr val="1F3B57"/>
+                </a:solidFill>
+              </a:defRPr>
+            </a:pPr>
+            <a:r>
+              <a:t>• Experiment: 14 questions that triggered web, Tavily backend, measured answer flips vs no-web:</a:t>
             </a:r>
           </a:p>
         </p:txBody>
       </p:sp>
       <p:graphicFrame>
         <p:nvGraphicFramePr>
-          <p:cNvPr id="3" name="Table 2"/>
+          <p:cNvPr id="4" name="Table 3"/>
           <p:cNvGraphicFramePr>
             <a:graphicFrameLocks noGrp="1"/>
           </p:cNvGraphicFramePr>
           <p:nvPr/>
         </p:nvGraphicFramePr>
         <p:xfrm>
-          <a:off x="365760" y="1280160"/>
-          <a:ext cx="11430000" cy="4389120"/>
+          <a:off x="731520" y="1828800"/>
+          <a:ext cx="8229600" cy="1554480"/>
         </p:xfrm>
         <a:graphic>
           <a:graphicData uri="http://schemas.openxmlformats.org/drawingml/2006/table">
@@ -3560,12 +3811,13 @@
                 <a:tableStyleId>{5C22544A-7EE6-4342-B048-85BDC9FD1C3A}</a:tableStyleId>
               </a:tblPr>
               <a:tblGrid>
-                <a:gridCol w="2286000"/>
-                <a:gridCol w="2926080"/>
-                <a:gridCol w="3291840"/>
-                <a:gridCol w="2926080"/>
+                <a:gridCol w="2194560"/>
+                <a:gridCol w="1554480"/>
+                <a:gridCol w="1554480"/>
+                <a:gridCol w="2011680"/>
+                <a:gridCol w="914400"/>
               </a:tblGrid>
-              <a:tr h="1097280">
+              <a:tr h="518160">
                 <a:tc>
                   <a:txBody>
                     <a:bodyPr/>
@@ -3579,7 +3831,7 @@
                         </a:defRPr>
                       </a:pPr>
                       <a:r>
-                        <a:t>Paper</a:t>
+                        <a:t>Question type</a:t>
                       </a:r>
                     </a:p>
                   </a:txBody>
@@ -3602,7 +3854,7 @@
                         </a:defRPr>
                       </a:pPr>
                       <a:r>
-                        <a:t>Inspiration we took</a:t>
+                        <a:t>Web fired on</a:t>
                       </a:r>
                     </a:p>
                   </a:txBody>
@@ -3625,7 +3877,7 @@
                         </a:defRPr>
                       </a:pPr>
                       <a:r>
-                        <a:t>Our strategy change</a:t>
+                        <a:t>Fixed</a:t>
                       </a:r>
                     </a:p>
                   </a:txBody>
@@ -3648,7 +3900,30 @@
                         </a:defRPr>
                       </a:pPr>
                       <a:r>
-                        <a:t>Measured effect</a:t>
+                        <a:t>Broke</a:t>
+                      </a:r>
+                    </a:p>
+                  </a:txBody>
+                  <a:tcPr>
+                    <a:solidFill>
+                      <a:srgbClr val="1F3B57"/>
+                    </a:solidFill>
+                  </a:tcPr>
+                </a:tc>
+                <a:tc>
+                  <a:txBody>
+                    <a:bodyPr/>
+                    <a:lstStyle/>
+                    <a:p>
+                      <a:pPr>
+                        <a:defRPr sz="1300" b="1">
+                          <a:solidFill>
+                            <a:srgbClr val="FFFFFF"/>
+                          </a:solidFill>
+                        </a:defRPr>
+                      </a:pPr>
+                      <a:r>
+                        <a:t>Net</a:t>
                       </a:r>
                     </a:p>
                   </a:txBody>
@@ -3659,25 +3934,17 @@
                   </a:tcPr>
                 </a:tc>
               </a:tr>
-              <a:tr h="1097280">
+              <a:tr h="518160">
                 <a:tc>
                   <a:txBody>
                     <a:bodyPr/>
                     <a:lstStyle/>
                     <a:p>
                       <a:pPr>
-                        <a:defRPr sz="1200" b="1"/>
+                        <a:defRPr sz="1300" b="1"/>
                       </a:pPr>
                       <a:r>
-                        <a:t>ItV — Knowing What's</a:t>
-                      </a:r>
-                    </a:p>
-                    <a:p>
-                      <a:pPr>
-                        <a:defRPr sz="1200" b="1"/>
-                      </a:pPr>
-                      <a:r>
-                        <a:t>Missing (EACL'26)</a:t>
+                        <a:t>MC (pick best option)</a:t>
                       </a:r>
                     </a:p>
                   </a:txBody>
@@ -3689,18 +3956,10 @@
                     <a:lstStyle/>
                     <a:p>
                       <a:pPr>
-                        <a:defRPr sz="1200" b="0"/>
+                        <a:defRPr sz="1300" b="0"/>
                       </a:pPr>
                       <a:r>
-                        <a:t>Identify-then-Verify</a:t>
-                      </a:r>
-                    </a:p>
-                    <a:p>
-                      <a:pPr>
-                        <a:defRPr sz="1200" b="0"/>
-                      </a:pPr>
-                      <a:r>
-                        <a:t>sufficiency check</a:t>
+                        <a:t>4</a:t>
                       </a:r>
                     </a:p>
                   </a:txBody>
@@ -3712,18 +3971,10 @@
                     <a:lstStyle/>
                     <a:p>
                       <a:pPr>
-                        <a:defRPr sz="1200" b="0"/>
+                        <a:defRPr sz="1300" b="0"/>
                       </a:pPr>
                       <a:r>
-                        <a:t>Chained detection → gap-query →</a:t>
-                      </a:r>
-                    </a:p>
-                    <a:p>
-                      <a:pPr>
-                        <a:defRPr sz="1200" b="0"/>
-                      </a:pPr>
-                      <a:r>
-                        <a:t>completion (paper stops at detection)</a:t>
+                        <a:t>1  (MC_016)</a:t>
                       </a:r>
                     </a:p>
                   </a:txBody>
@@ -3735,35 +3986,10 @@
                     <a:lstStyle/>
                     <a:p>
                       <a:pPr>
-                        <a:defRPr sz="1200" b="0"/>
+                        <a:defRPr sz="1300" b="0"/>
                       </a:pPr>
                       <a:r>
-                        <a:t>Sufficiency AUC 0.73 —</a:t>
-                      </a:r>
-                    </a:p>
-                    <a:p>
-                      <a:pPr>
-                        <a:defRPr sz="1200" b="0"/>
-                      </a:pPr>
-                      <a:r>
-                        <a:t>best of all evaluators</a:t>
-                      </a:r>
-                    </a:p>
-                  </a:txBody>
-                  <a:tcPr/>
-                </a:tc>
-              </a:tr>
-              <a:tr h="1097280">
-                <a:tc>
-                  <a:txBody>
-                    <a:bodyPr/>
-                    <a:lstStyle/>
-                    <a:p>
-                      <a:pPr>
-                        <a:defRPr sz="1200" b="1"/>
-                      </a:pPr>
-                      <a:r>
-                        <a:t>CRAG (2401.15884)</a:t>
+                        <a:t>0</a:t>
                       </a:r>
                     </a:p>
                   </a:txBody>
@@ -3775,18 +4001,27 @@
                     <a:lstStyle/>
                     <a:p>
                       <a:pPr>
-                        <a:defRPr sz="1200" b="0"/>
+                        <a:defRPr sz="1300" b="0"/>
                       </a:pPr>
                       <a:r>
-                        <a:t>Corrective web retrieval;</a:t>
+                        <a:t>+1</a:t>
                       </a:r>
                     </a:p>
+                  </a:txBody>
+                  <a:tcPr/>
+                </a:tc>
+              </a:tr>
+              <a:tr h="518160">
+                <a:tc>
+                  <a:txBody>
+                    <a:bodyPr/>
+                    <a:lstStyle/>
                     <a:p>
                       <a:pPr>
-                        <a:defRPr sz="1200" b="0"/>
+                        <a:defRPr sz="1300" b="1"/>
                       </a:pPr>
                       <a:r>
-                        <a:t>a trained relevance evaluator</a:t>
+                        <a:t>TF (binary true/false)</a:t>
                       </a:r>
                     </a:p>
                   </a:txBody>
@@ -3798,18 +4033,10 @@
                     <a:lstStyle/>
                     <a:p>
                       <a:pPr>
-                        <a:defRPr sz="1200" b="0"/>
+                        <a:defRPr sz="1300" b="0"/>
                       </a:pPr>
                       <a:r>
-                        <a:t>Replaced relevance evaluator with our</a:t>
-                      </a:r>
-                    </a:p>
-                    <a:p>
-                      <a:pPr>
-                        <a:defRPr sz="1200" b="0"/>
-                      </a:pPr>
-                      <a:r>
-                        <a:t>sufficiency gate; made web type-aware</a:t>
+                        <a:t>~8</a:t>
                       </a:r>
                     </a:p>
                   </a:txBody>
@@ -3821,35 +4048,10 @@
                     <a:lstStyle/>
                     <a:p>
                       <a:pPr>
-                        <a:defRPr sz="1200" b="0"/>
+                        <a:defRPr sz="1300" b="0"/>
                       </a:pPr>
                       <a:r>
-                        <a:t>Their evaluator on our data 0.47</a:t>
-                      </a:r>
-                    </a:p>
-                    <a:p>
-                      <a:pPr>
-                        <a:defRPr sz="1200" b="0"/>
-                      </a:pPr>
-                      <a:r>
-                        <a:t>→ our gate 0.73; type-aware web +3</a:t>
-                      </a:r>
-                    </a:p>
-                  </a:txBody>
-                  <a:tcPr/>
-                </a:tc>
-              </a:tr>
-              <a:tr h="1097280">
-                <a:tc>
-                  <a:txBody>
-                    <a:bodyPr/>
-                    <a:lstStyle/>
-                    <a:p>
-                      <a:pPr>
-                        <a:defRPr sz="1200" b="1"/>
-                      </a:pPr>
-                      <a:r>
-                        <a:t>MIGRES (2404.14043)</a:t>
+                        <a:t>0</a:t>
                       </a:r>
                     </a:p>
                   </a:txBody>
@@ -3861,18 +4063,10 @@
                     <a:lstStyle/>
                     <a:p>
                       <a:pPr>
-                        <a:defRPr sz="1200" b="0"/>
+                        <a:defRPr sz="1300" b="0"/>
                       </a:pPr>
                       <a:r>
-                        <a:t>Missing-info → targeted</a:t>
-                      </a:r>
-                    </a:p>
-                    <a:p>
-                      <a:pPr>
-                        <a:defRPr sz="1200" b="0"/>
-                      </a:pPr>
-                      <a:r>
-                        <a:t>sub-queries; sentence denoising</a:t>
+                        <a:t>2  (TF_035, TF_046)</a:t>
                       </a:r>
                     </a:p>
                   </a:txBody>
@@ -3884,18 +4078,501 @@
                     <a:lstStyle/>
                     <a:p>
                       <a:pPr>
-                        <a:defRPr sz="1200" b="0"/>
+                        <a:defRPr sz="1300" b="0"/>
                       </a:pPr>
                       <a:r>
-                        <a:t>Local-first before web;</a:t>
+                        <a:t>−2</a:t>
                       </a:r>
                     </a:p>
+                  </a:txBody>
+                  <a:tcPr/>
+                </a:tc>
+              </a:tr>
+            </a:tbl>
+          </a:graphicData>
+        </a:graphic>
+      </p:graphicFrame>
+      <p:sp>
+        <p:nvSpPr>
+          <p:cNvPr id="5" name="TextBox 4"/>
+          <p:cNvSpPr txBox="1"/>
+          <p:nvPr/>
+        </p:nvSpPr>
+        <p:spPr>
+          <a:xfrm>
+            <a:off x="640080" y="3657600"/>
+            <a:ext cx="11064240" cy="2743200"/>
+          </a:xfrm>
+          <a:prstGeom prst="rect">
+            <a:avLst/>
+          </a:prstGeom>
+          <a:noFill/>
+        </p:spPr>
+        <p:txBody>
+          <a:bodyPr wrap="square">
+            <a:spAutoFit/>
+          </a:bodyPr>
+          <a:lstStyle/>
+          <a:p>
+            <a:pPr>
+              <a:spcAft>
+                <a:spcPts val="400"/>
+              </a:spcAft>
+              <a:defRPr sz="1400"/>
+            </a:pPr>
+            <a:r>
+              <a:t>• Analysis: MC = pick-best-option → more evidence helps;  TF = binary entailment → extra/contradicting sentences flip the verdict</a:t>
+            </a:r>
+          </a:p>
+          <a:p>
+            <a:pPr>
+              <a:spcAft>
+                <a:spcPts val="400"/>
+              </a:spcAft>
+              <a:defRPr sz="1400" b="1">
+                <a:solidFill>
+                  <a:srgbClr val="B45F06"/>
+                </a:solidFill>
+              </a:defRPr>
+            </a:pPr>
+            <a:r>
+              <a:t>• Decision: fire web for MC only; TF keeps gap-local (local, noise-free)</a:t>
+            </a:r>
+          </a:p>
+          <a:p>
+            <a:pPr>
+              <a:spcAft>
+                <a:spcPts val="400"/>
+              </a:spcAft>
+              <a:defRPr sz="1400" b="0">
+                <a:solidFill>
+                  <a:srgbClr val="38761D"/>
+                </a:solidFill>
+              </a:defRPr>
+            </a:pPr>
+            <a:r>
+              <a:t>• Effect: +3 on full 149 (135 → 138); TF rose to 111/120</a:t>
+            </a:r>
+          </a:p>
+          <a:p>
+            <a:pPr>
+              <a:spcAft>
+                <a:spcPts val="400"/>
+              </a:spcAft>
+              <a:defRPr sz="1400" b="0">
+                <a:solidFill>
+                  <a:srgbClr val="38761D"/>
+                </a:solidFill>
+              </a:defRPr>
+            </a:pPr>
+            <a:r>
+              <a:t>• Why it generalizes: applies to any selection-vs-verification task split</a:t>
+            </a:r>
+          </a:p>
+        </p:txBody>
+      </p:sp>
+    </p:spTree>
+  </p:cSld>
+  <p:clrMapOvr>
+    <a:masterClrMapping/>
+  </p:clrMapOvr>
+</p:sld>
+</file>
+
+<file path=ppt/slides/slide6.xml><?xml version="1.0" encoding="utf-8"?>
+<p:sld xmlns:a="http://schemas.openxmlformats.org/drawingml/2006/main" xmlns:p="http://schemas.openxmlformats.org/presentationml/2006/main" xmlns:r="http://schemas.openxmlformats.org/officeDocument/2006/relationships">
+  <p:cSld>
+    <p:spTree>
+      <p:nvGrpSpPr>
+        <p:cNvPr id="1" name=""/>
+        <p:cNvGrpSpPr/>
+        <p:nvPr/>
+      </p:nvGrpSpPr>
+      <p:grpSpPr/>
+      <p:sp>
+        <p:nvSpPr>
+          <p:cNvPr id="2" name="TextBox 1"/>
+          <p:cNvSpPr txBox="1"/>
+          <p:nvPr/>
+        </p:nvSpPr>
+        <p:spPr>
+          <a:xfrm>
+            <a:off x="457200" y="201168"/>
+            <a:ext cx="11338560" cy="868680"/>
+          </a:xfrm>
+          <a:prstGeom prst="rect">
+            <a:avLst/>
+          </a:prstGeom>
+          <a:noFill/>
+        </p:spPr>
+        <p:txBody>
+          <a:bodyPr wrap="square">
+            <a:spAutoFit/>
+          </a:bodyPr>
+          <a:lstStyle/>
+          <a:p>
+            <a:pPr>
+              <a:defRPr sz="2600" b="1">
+                <a:solidFill>
+                  <a:srgbClr val="1F3B57"/>
+                </a:solidFill>
+              </a:defRPr>
+            </a:pPr>
+            <a:r>
+              <a:t>④ Denoised Corrective Retrieval</a:t>
+            </a:r>
+          </a:p>
+          <a:p>
+            <a:pPr>
+              <a:defRPr sz="1300">
+                <a:solidFill>
+                  <a:srgbClr val="555555"/>
+                </a:solidFill>
+              </a:defRPr>
+            </a:pPr>
+            <a:r>
+              <a:t>Bring external knowledge in WITHOUT flooding the answer</a:t>
+            </a:r>
+          </a:p>
+        </p:txBody>
+      </p:sp>
+      <p:sp>
+        <p:nvSpPr>
+          <p:cNvPr id="3" name="TextBox 2"/>
+          <p:cNvSpPr txBox="1"/>
+          <p:nvPr/>
+        </p:nvSpPr>
+        <p:spPr>
+          <a:xfrm>
+            <a:off x="640080" y="1280160"/>
+            <a:ext cx="11064240" cy="5212080"/>
+          </a:xfrm>
+          <a:prstGeom prst="rect">
+            <a:avLst/>
+          </a:prstGeom>
+          <a:noFill/>
+        </p:spPr>
+        <p:txBody>
+          <a:bodyPr wrap="square">
+            <a:spAutoFit/>
+          </a:bodyPr>
+          <a:lstStyle/>
+          <a:p>
+            <a:pPr>
+              <a:spcAft>
+                <a:spcPts val="400"/>
+              </a:spcAft>
+              <a:defRPr sz="1400" b="1">
+                <a:solidFill>
+                  <a:srgbClr val="1F3B57"/>
+                </a:solidFill>
+              </a:defRPr>
+            </a:pPr>
+            <a:r>
+              <a:t>• Per external source (Tavily / PubMed):</a:t>
+            </a:r>
+          </a:p>
+          <a:p>
+            <a:pPr lvl="1">
+              <a:spcAft>
+                <a:spcPts val="400"/>
+              </a:spcAft>
+              <a:defRPr sz="1300"/>
+            </a:pPr>
+            <a:r>
+              <a:t>    – sentence-split → drop boilerplate/junk (regex filter) &amp; sentences &lt;15 chars → cap 12 sentences/source</a:t>
+            </a:r>
+          </a:p>
+          <a:p>
+            <a:pPr lvl="1">
+              <a:spcAft>
+                <a:spcPts val="400"/>
+              </a:spcAft>
+              <a:defRPr sz="1300"/>
+            </a:pPr>
+            <a:r>
+              <a:t>    – near-duplicate dedup across sources</a:t>
+            </a:r>
+          </a:p>
+          <a:p>
+            <a:pPr>
+              <a:spcAft>
+                <a:spcPts val="400"/>
+              </a:spcAft>
+              <a:defRPr sz="1400" b="1">
+                <a:solidFill>
+                  <a:srgbClr val="1F3B57"/>
+                </a:solidFill>
+              </a:defRPr>
+            </a:pPr>
+            <a:r>
+              <a:t>• Before merging:</a:t>
+            </a:r>
+          </a:p>
+          <a:p>
+            <a:pPr lvl="1">
+              <a:spcAft>
+                <a:spcPts val="400"/>
+              </a:spcAft>
+              <a:defRPr sz="1300"/>
+            </a:pPr>
+            <a:r>
+              <a:t>    – relevance pre-filter — rerank web sentences vs question, keep top-20</a:t>
+            </a:r>
+          </a:p>
+          <a:p>
+            <a:pPr>
+              <a:spcAft>
+                <a:spcPts val="400"/>
+              </a:spcAft>
+              <a:defRPr sz="1400" b="1">
+                <a:solidFill>
+                  <a:srgbClr val="1F3B57"/>
+                </a:solidFill>
+              </a:defRPr>
+            </a:pPr>
+            <a:r>
+              <a:t>• Merge &amp; select:</a:t>
+            </a:r>
+          </a:p>
+          <a:p>
+            <a:pPr lvl="1">
+              <a:spcAft>
+                <a:spcPts val="400"/>
+              </a:spcAft>
+              <a:defRPr sz="1300"/>
+            </a:pPr>
+            <a:r>
+              <a:t>    – merge web + local → GLOBAL cross-encoder rerank (bge-reranker-v2-m3)</a:t>
+            </a:r>
+          </a:p>
+          <a:p>
+            <a:pPr lvl="1">
+              <a:spcAft>
+                <a:spcPts val="400"/>
+              </a:spcAft>
+              <a:defRPr sz="1300"/>
+            </a:pPr>
+            <a:r>
+              <a:t>    – local-floor guard: reserve ≥8 of top-k for LOCAL passages so web can't crowd out the answer (over-cap web deferred)</a:t>
+            </a:r>
+          </a:p>
+          <a:p>
+            <a:pPr>
+              <a:spcAft>
+                <a:spcPts val="400"/>
+              </a:spcAft>
+              <a:defRPr sz="1400" b="1">
+                <a:solidFill>
+                  <a:srgbClr val="B45F06"/>
+                </a:solidFill>
+              </a:defRPr>
+            </a:pPr>
+            <a:r>
+              <a:t>• Do we store the external knowledge back into the KB?</a:t>
+            </a:r>
+          </a:p>
+          <a:p>
+            <a:pPr lvl="1">
+              <a:spcAft>
+                <a:spcPts val="400"/>
+              </a:spcAft>
+              <a:defRPr sz="1300"/>
+            </a:pPr>
+            <a:r>
+              <a:t>    – No — results are CACHED by query hash (reproducibility), but NOT persisted to the vector store; used in-context per question only</a:t>
+            </a:r>
+          </a:p>
+          <a:p>
+            <a:pPr lvl="1">
+              <a:spcAft>
+                <a:spcPts val="400"/>
+              </a:spcAft>
+              <a:defRPr sz="1300" b="0">
+                <a:solidFill>
+                  <a:srgbClr val="555555"/>
+                </a:solidFill>
+              </a:defRPr>
+            </a:pPr>
+            <a:r>
+              <a:t>    – Future improvement: persist ItV-verified external facts back into the KB to grow it over time</a:t>
+            </a:r>
+          </a:p>
+          <a:p>
+            <a:pPr>
+              <a:spcAft>
+                <a:spcPts val="400"/>
+              </a:spcAft>
+              <a:defRPr sz="1400" b="0">
+                <a:solidFill>
+                  <a:srgbClr val="38761D"/>
+                </a:solidFill>
+              </a:defRPr>
+            </a:pPr>
+            <a:r>
+              <a:t>• Why it generalizes: a standard denoising chain for any web-augmented RAG</a:t>
+            </a:r>
+          </a:p>
+        </p:txBody>
+      </p:sp>
+    </p:spTree>
+  </p:cSld>
+  <p:clrMapOvr>
+    <a:masterClrMapping/>
+  </p:clrMapOvr>
+</p:sld>
+</file>
+
+<file path=ppt/slides/slide7.xml><?xml version="1.0" encoding="utf-8"?>
+<p:sld xmlns:a="http://schemas.openxmlformats.org/drawingml/2006/main" xmlns:p="http://schemas.openxmlformats.org/presentationml/2006/main" xmlns:r="http://schemas.openxmlformats.org/officeDocument/2006/relationships">
+  <p:cSld>
+    <p:spTree>
+      <p:nvGrpSpPr>
+        <p:cNvPr id="1" name=""/>
+        <p:cNvGrpSpPr/>
+        <p:nvPr/>
+      </p:nvGrpSpPr>
+      <p:grpSpPr/>
+      <p:sp>
+        <p:nvSpPr>
+          <p:cNvPr id="2" name="TextBox 1"/>
+          <p:cNvSpPr txBox="1"/>
+          <p:nvPr/>
+        </p:nvSpPr>
+        <p:spPr>
+          <a:xfrm>
+            <a:off x="457200" y="201168"/>
+            <a:ext cx="11338560" cy="868680"/>
+          </a:xfrm>
+          <a:prstGeom prst="rect">
+            <a:avLst/>
+          </a:prstGeom>
+          <a:noFill/>
+        </p:spPr>
+        <p:txBody>
+          <a:bodyPr wrap="square">
+            <a:spAutoFit/>
+          </a:bodyPr>
+          <a:lstStyle/>
+          <a:p>
+            <a:pPr>
+              <a:defRPr sz="2600" b="1">
+                <a:solidFill>
+                  <a:srgbClr val="1F3B57"/>
+                </a:solidFill>
+              </a:defRPr>
+            </a:pPr>
+            <a:r>
+              <a:t>Ablation — Effect of Each Strategy</a:t>
+            </a:r>
+          </a:p>
+        </p:txBody>
+      </p:sp>
+      <p:graphicFrame>
+        <p:nvGraphicFramePr>
+          <p:cNvPr id="3" name="Table 2"/>
+          <p:cNvGraphicFramePr>
+            <a:graphicFrameLocks noGrp="1"/>
+          </p:cNvGraphicFramePr>
+          <p:nvPr/>
+        </p:nvGraphicFramePr>
+        <p:xfrm>
+          <a:off x="548640" y="1371600"/>
+          <a:ext cx="11064240" cy="4114800"/>
+        </p:xfrm>
+        <a:graphic>
+          <a:graphicData uri="http://schemas.openxmlformats.org/drawingml/2006/table">
+            <a:tbl>
+              <a:tblPr firstRow="1" bandRow="1">
+                <a:tableStyleId>{5C22544A-7EE6-4342-B048-85BDC9FD1C3A}</a:tableStyleId>
+              </a:tblPr>
+              <a:tblGrid>
+                <a:gridCol w="4754880"/>
+                <a:gridCol w="3108960"/>
+                <a:gridCol w="3200400"/>
+              </a:tblGrid>
+              <a:tr h="685800">
+                <a:tc>
+                  <a:txBody>
+                    <a:bodyPr/>
+                    <a:lstStyle/>
                     <a:p>
                       <a:pPr>
-                        <a:defRPr sz="1200" b="0"/>
+                        <a:defRPr sz="1400" b="1">
+                          <a:solidFill>
+                            <a:srgbClr val="FFFFFF"/>
+                          </a:solidFill>
+                        </a:defRPr>
                       </a:pPr>
                       <a:r>
-                        <a:t>type-aware routing</a:t>
+                        <a:t>Strategy removed</a:t>
+                      </a:r>
+                    </a:p>
+                  </a:txBody>
+                  <a:tcPr>
+                    <a:solidFill>
+                      <a:srgbClr val="1F3B57"/>
+                    </a:solidFill>
+                  </a:tcPr>
+                </a:tc>
+                <a:tc>
+                  <a:txBody>
+                    <a:bodyPr/>
+                    <a:lstStyle/>
+                    <a:p>
+                      <a:pPr>
+                        <a:defRPr sz="1400" b="1">
+                          <a:solidFill>
+                            <a:srgbClr val="FFFFFF"/>
+                          </a:solidFill>
+                        </a:defRPr>
+                      </a:pPr>
+                      <a:r>
+                        <a:t>Measured on</a:t>
+                      </a:r>
+                    </a:p>
+                  </a:txBody>
+                  <a:tcPr>
+                    <a:solidFill>
+                      <a:srgbClr val="1F3B57"/>
+                    </a:solidFill>
+                  </a:tcPr>
+                </a:tc>
+                <a:tc>
+                  <a:txBody>
+                    <a:bodyPr/>
+                    <a:lstStyle/>
+                    <a:p>
+                      <a:pPr>
+                        <a:defRPr sz="1400" b="1">
+                          <a:solidFill>
+                            <a:srgbClr val="FFFFFF"/>
+                          </a:solidFill>
+                        </a:defRPr>
+                      </a:pPr>
+                      <a:r>
+                        <a:t>Effect</a:t>
+                      </a:r>
+                    </a:p>
+                  </a:txBody>
+                  <a:tcPr>
+                    <a:solidFill>
+                      <a:srgbClr val="1F3B57"/>
+                    </a:solidFill>
+                  </a:tcPr>
+                </a:tc>
+              </a:tr>
+              <a:tr h="685800">
+                <a:tc>
+                  <a:txBody>
+                    <a:bodyPr/>
+                    <a:lstStyle/>
+                    <a:p>
+                      <a:pPr>
+                        <a:defRPr sz="1300" b="1"/>
+                      </a:pPr>
+                      <a:r>
+                        <a:t>Type-aware routing  (→ web on TF too)</a:t>
                       </a:r>
                     </a:p>
                   </a:txBody>
@@ -3907,18 +4584,213 @@
                     <a:lstStyle/>
                     <a:p>
                       <a:pPr>
-                        <a:defRPr sz="1200" b="0"/>
+                        <a:defRPr sz="1300" b="0"/>
                       </a:pPr>
                       <a:r>
-                        <a:t>Gap-local recovers in-KB</a:t>
+                        <a:t>full 149</a:t>
                       </a:r>
                     </a:p>
+                  </a:txBody>
+                  <a:tcPr/>
+                </a:tc>
+                <a:tc>
+                  <a:txBody>
+                    <a:bodyPr/>
+                    <a:lstStyle/>
                     <a:p>
                       <a:pPr>
-                        <a:defRPr sz="1200" b="0"/>
+                        <a:defRPr sz="1300" b="0"/>
                       </a:pPr>
                       <a:r>
-                        <a:t>buried answers, for free</a:t>
+                        <a:t>138 → 135   (−3)</a:t>
+                      </a:r>
+                    </a:p>
+                  </a:txBody>
+                  <a:tcPr/>
+                </a:tc>
+              </a:tr>
+              <a:tr h="685800">
+                <a:tc>
+                  <a:txBody>
+                    <a:bodyPr/>
+                    <a:lstStyle/>
+                    <a:p>
+                      <a:pPr>
+                        <a:defRPr sz="1300" b="1"/>
+                      </a:pPr>
+                      <a:r>
+                        <a:t>Corrective web backend  (Tavily → DuckDuckGo)</a:t>
+                      </a:r>
+                    </a:p>
+                  </a:txBody>
+                  <a:tcPr/>
+                </a:tc>
+                <a:tc>
+                  <a:txBody>
+                    <a:bodyPr/>
+                    <a:lstStyle/>
+                    <a:p>
+                      <a:pPr>
+                        <a:defRPr sz="1300" b="0"/>
+                      </a:pPr>
+                      <a:r>
+                        <a:t>web-firing MC subset</a:t>
+                      </a:r>
+                    </a:p>
+                  </a:txBody>
+                  <a:tcPr/>
+                </a:tc>
+                <a:tc>
+                  <a:txBody>
+                    <a:bodyPr/>
+                    <a:lstStyle/>
+                    <a:p>
+                      <a:pPr>
+                        <a:defRPr sz="1300" b="0"/>
+                      </a:pPr>
+                      <a:r>
+                        <a:t>loses MC_016 (DDG: 0 confirming hits)</a:t>
+                      </a:r>
+                    </a:p>
+                  </a:txBody>
+                  <a:tcPr/>
+                </a:tc>
+              </a:tr>
+              <a:tr h="685800">
+                <a:tc>
+                  <a:txBody>
+                    <a:bodyPr/>
+                    <a:lstStyle/>
+                    <a:p>
+                      <a:pPr>
+                        <a:defRPr sz="1300" b="1"/>
+                      </a:pPr>
+                      <a:r>
+                        <a:t>Gap-local re-retrieval</a:t>
+                      </a:r>
+                    </a:p>
+                  </a:txBody>
+                  <a:tcPr/>
+                </a:tc>
+                <a:tc>
+                  <a:txBody>
+                    <a:bodyPr/>
+                    <a:lstStyle/>
+                    <a:p>
+                      <a:pPr>
+                        <a:defRPr sz="1300" b="0"/>
+                      </a:pPr>
+                      <a:r>
+                        <a:t>gate-blocked 6-Q subset</a:t>
+                      </a:r>
+                    </a:p>
+                  </a:txBody>
+                  <a:tcPr/>
+                </a:tc>
+                <a:tc>
+                  <a:txBody>
+                    <a:bodyPr/>
+                    <a:lstStyle/>
+                    <a:p>
+                      <a:pPr>
+                        <a:defRPr sz="1300" b="0"/>
+                      </a:pPr>
+                      <a:r>
+                        <a:t>−2 recovered answers</a:t>
+                      </a:r>
+                    </a:p>
+                  </a:txBody>
+                  <a:tcPr/>
+                </a:tc>
+              </a:tr>
+              <a:tr h="685800">
+                <a:tc>
+                  <a:txBody>
+                    <a:bodyPr/>
+                    <a:lstStyle/>
+                    <a:p>
+                      <a:pPr>
+                        <a:defRPr sz="1300" b="1"/>
+                      </a:pPr>
+                      <a:r>
+                        <a:t>Sufficiency gate  (ItV → NLI answerability)</a:t>
+                      </a:r>
+                    </a:p>
+                  </a:txBody>
+                  <a:tcPr/>
+                </a:tc>
+                <a:tc>
+                  <a:txBody>
+                    <a:bodyPr/>
+                    <a:lstStyle/>
+                    <a:p>
+                      <a:pPr>
+                        <a:defRPr sz="1300" b="0"/>
+                      </a:pPr>
+                      <a:r>
+                        <a:t>sufficiency AUC</a:t>
+                      </a:r>
+                    </a:p>
+                  </a:txBody>
+                  <a:tcPr/>
+                </a:tc>
+                <a:tc>
+                  <a:txBody>
+                    <a:bodyPr/>
+                    <a:lstStyle/>
+                    <a:p>
+                      <a:pPr>
+                        <a:defRPr sz="1300" b="0"/>
+                      </a:pPr>
+                      <a:r>
+                        <a:t>0.73 → 0.675</a:t>
+                      </a:r>
+                    </a:p>
+                  </a:txBody>
+                  <a:tcPr/>
+                </a:tc>
+              </a:tr>
+              <a:tr h="685800">
+                <a:tc>
+                  <a:txBody>
+                    <a:bodyPr/>
+                    <a:lstStyle/>
+                    <a:p>
+                      <a:pPr>
+                        <a:defRPr sz="1300" b="1"/>
+                      </a:pPr>
+                      <a:r>
+                        <a:t>Sufficiency gate  (ItV → CRAG off-the-shelf eval)</a:t>
+                      </a:r>
+                    </a:p>
+                  </a:txBody>
+                  <a:tcPr/>
+                </a:tc>
+                <a:tc>
+                  <a:txBody>
+                    <a:bodyPr/>
+                    <a:lstStyle/>
+                    <a:p>
+                      <a:pPr>
+                        <a:defRPr sz="1300" b="0"/>
+                      </a:pPr>
+                      <a:r>
+                        <a:t>sufficiency AUC</a:t>
+                      </a:r>
+                    </a:p>
+                  </a:txBody>
+                  <a:tcPr/>
+                </a:tc>
+                <a:tc>
+                  <a:txBody>
+                    <a:bodyPr/>
+                    <a:lstStyle/>
+                    <a:p>
+                      <a:pPr>
+                        <a:defRPr sz="1300" b="0"/>
+                      </a:pPr>
+                      <a:r>
+                        <a:t>0.73 → 0.47 (below random)</a:t>
                       </a:r>
                     </a:p>
                   </a:txBody>
@@ -3929,6 +4801,44 @@
           </a:graphicData>
         </a:graphic>
       </p:graphicFrame>
+      <p:sp>
+        <p:nvSpPr>
+          <p:cNvPr id="4" name="TextBox 3"/>
+          <p:cNvSpPr txBox="1"/>
+          <p:nvPr/>
+        </p:nvSpPr>
+        <p:spPr>
+          <a:xfrm>
+            <a:off x="548640" y="5715000"/>
+            <a:ext cx="11064240" cy="822960"/>
+          </a:xfrm>
+          <a:prstGeom prst="rect">
+            <a:avLst/>
+          </a:prstGeom>
+          <a:noFill/>
+        </p:spPr>
+        <p:txBody>
+          <a:bodyPr wrap="square">
+            <a:spAutoFit/>
+          </a:bodyPr>
+          <a:lstStyle/>
+          <a:p>
+            <a:pPr>
+              <a:spcAft>
+                <a:spcPts val="400"/>
+              </a:spcAft>
+              <a:defRPr sz="1200" b="0">
+                <a:solidFill>
+                  <a:srgbClr val="555555"/>
+                </a:solidFill>
+              </a:defRPr>
+            </a:pPr>
+            <a:r>
+              <a:t>• Mixed scope (full-149 where available, else AUC / targeted subset) — labeled per row; full per-component 149 ablations are a next step</a:t>
+            </a:r>
+          </a:p>
+        </p:txBody>
+      </p:sp>
     </p:spTree>
   </p:cSld>
   <p:clrMapOvr>
@@ -3937,7 +4847,7 @@
 </p:sld>
 </file>
 
-<file path=ppt/slides/slide5.xml><?xml version="1.0" encoding="utf-8"?>
+<file path=ppt/slides/slide8.xml><?xml version="1.0" encoding="utf-8"?>
 <p:sld xmlns:a="http://schemas.openxmlformats.org/drawingml/2006/main" xmlns:p="http://schemas.openxmlformats.org/presentationml/2006/main" xmlns:r="http://schemas.openxmlformats.org/officeDocument/2006/relationships">
   <p:cSld>
     <p:spTree>
@@ -3955,8 +4865,8 @@
         </p:nvSpPr>
         <p:spPr>
           <a:xfrm>
-            <a:off x="457200" y="228600"/>
-            <a:ext cx="11247120" cy="868680"/>
+            <a:off x="457200" y="201168"/>
+            <a:ext cx="11338560" cy="868680"/>
           </a:xfrm>
           <a:prstGeom prst="rect">
             <a:avLst/>
@@ -3970,7 +4880,7 @@
           <a:lstStyle/>
           <a:p>
             <a:pPr>
-              <a:defRPr sz="2800" b="1">
+              <a:defRPr sz="2600" b="1">
                 <a:solidFill>
                   <a:srgbClr val="1F3B57"/>
                 </a:solidFill>
@@ -4030,7 +4940,7 @@
           <a:p>
             <a:pPr>
               <a:spcAft>
-                <a:spcPts val="600"/>
+                <a:spcPts val="400"/>
               </a:spcAft>
               <a:defRPr sz="1300" b="1">
                 <a:solidFill>
@@ -4039,13 +4949,13 @@
               </a:defRPr>
             </a:pPr>
             <a:r>
-              <a:t>• Using CRAG's off-the-shelf evaluator directly on our data: AUC 0.47 (below random)</a:t>
+              <a:t>• CRAG's off-the-shelf evaluator, used directly on our data: AUC 0.47 (below random)</a:t>
             </a:r>
           </a:p>
           <a:p>
             <a:pPr>
               <a:spcAft>
-                <a:spcPts val="600"/>
+                <a:spcPts val="400"/>
               </a:spcAft>
               <a:defRPr sz="1300" b="1">
                 <a:solidFill>
@@ -4054,26 +4964,26 @@
               </a:defRPr>
             </a:pPr>
             <a:r>
-              <a:t>• Our ItV-based sufficiency strategy: AUC 0.73</a:t>
+              <a:t>• Our ItV sufficiency strategy: AUC 0.73</a:t>
             </a:r>
           </a:p>
           <a:p>
             <a:pPr>
               <a:spcAft>
-                <a:spcPts val="600"/>
+                <a:spcPts val="400"/>
               </a:spcAft>
-              <a:defRPr sz="1300" b="0"/>
-            </a:pPr>
-            <a:r>
-              <a:t>• AUC is dataset-agnostic — the gain reflects the STRATEGY, not benchmark tuning</a:t>
+              <a:defRPr sz="1300"/>
+            </a:pPr>
+            <a:r>
+              <a:t>• AUC is dataset-agnostic — the gain is the STRATEGY, not benchmark tuning</a:t>
             </a:r>
           </a:p>
           <a:p>
             <a:pPr>
               <a:spcAft>
-                <a:spcPts val="600"/>
+                <a:spcPts val="400"/>
               </a:spcAft>
-              <a:defRPr sz="1300" b="0"/>
+              <a:defRPr sz="1300"/>
             </a:pPr>
             <a:r>
               <a:t>• </a:t>
@@ -4082,11 +4992,11 @@
           <a:p>
             <a:pPr>
               <a:spcAft>
-                <a:spcPts val="600"/>
+                <a:spcPts val="400"/>
               </a:spcAft>
               <a:defRPr sz="1300" b="1">
                 <a:solidFill>
-                  <a:srgbClr val="B45F06"/>
+                  <a:srgbClr val="1F3B57"/>
                 </a:solidFill>
               </a:defRPr>
             </a:pPr>
@@ -4097,20 +5007,20 @@
           <a:p>
             <a:pPr lvl="1">
               <a:spcAft>
-                <a:spcPts val="600"/>
+                <a:spcPts val="400"/>
               </a:spcAft>
-              <a:defRPr sz="1100" b="0"/>
-            </a:pPr>
-            <a:r>
-              <a:t>    – 92.6% overall  ·  95.8% on unambiguous items</a:t>
+              <a:defRPr sz="1200"/>
+            </a:pPr>
+            <a:r>
+              <a:t>    – 92.6% overall · 95.8% on unambiguous items</a:t>
             </a:r>
           </a:p>
           <a:p>
             <a:pPr lvl="1">
               <a:spcAft>
-                <a:spcPts val="600"/>
+                <a:spcPts val="400"/>
               </a:spcAft>
-              <a:defRPr sz="1100" b="0"/>
+              <a:defRPr sz="1200"/>
             </a:pPr>
             <a:r>
               <a:t>    – frozen GPT-4 · free APIs · no fine-tuning</a:t>

</xml_diff>

<commit_message>
docs: multi-agent architecture design (figure + doc + slide)
Role-specialized orchestrated multi-agent design mapping the pipeline to agents:
orchestrator, evidence agents (local/gap/web), ItV judge panel, frozen answer agent,
NEW verify/debate panel (proponent-opponent-judge for TF binary judgments), optional
knowledge-curation agent. Honest note: only the debate panel is a net-new accuracy
lever and must be A/B-tested. Constraints preserved: frozen generator, free APIs.

Co-Authored-By: Claude Opus 4.8 (1M context) <noreply@anthropic.com>
</commit_message>
<xml_diff>
--- a/slides/ADRD_RAG_slides.pptx
+++ b/slides/ADRD_RAG_slides.pptx
@@ -13,6 +13,7 @@
     <p:sldId id="261" r:id="rId12"/>
     <p:sldId id="262" r:id="rId13"/>
     <p:sldId id="263" r:id="rId14"/>
+    <p:sldId id="264" r:id="rId15"/>
   </p:sldIdLst>
   <p:sldSz cx="12191695" cy="6858000" type="screen4x3"/>
   <p:notesSz cx="6858000" cy="9144000"/>
@@ -5036,6 +5037,211 @@
 </p:sld>
 </file>
 
+<file path=ppt/slides/slide9.xml><?xml version="1.0" encoding="utf-8"?>
+<p:sld xmlns:a="http://schemas.openxmlformats.org/drawingml/2006/main" xmlns:p="http://schemas.openxmlformats.org/presentationml/2006/main" xmlns:r="http://schemas.openxmlformats.org/officeDocument/2006/relationships">
+  <p:cSld>
+    <p:spTree>
+      <p:nvGrpSpPr>
+        <p:cNvPr id="1" name=""/>
+        <p:cNvGrpSpPr/>
+        <p:nvPr/>
+      </p:nvGrpSpPr>
+      <p:grpSpPr/>
+      <p:sp>
+        <p:nvSpPr>
+          <p:cNvPr id="2" name="TextBox 1"/>
+          <p:cNvSpPr txBox="1"/>
+          <p:nvPr/>
+        </p:nvSpPr>
+        <p:spPr>
+          <a:xfrm>
+            <a:off x="457200" y="201168"/>
+            <a:ext cx="11338560" cy="868680"/>
+          </a:xfrm>
+          <a:prstGeom prst="rect">
+            <a:avLst/>
+          </a:prstGeom>
+          <a:noFill/>
+        </p:spPr>
+        <p:txBody>
+          <a:bodyPr wrap="square">
+            <a:spAutoFit/>
+          </a:bodyPr>
+          <a:lstStyle/>
+          <a:p>
+            <a:pPr>
+              <a:defRPr sz="2600" b="1">
+                <a:solidFill>
+                  <a:srgbClr val="1F3B57"/>
+                </a:solidFill>
+              </a:defRPr>
+            </a:pPr>
+            <a:r>
+              <a:t>Multi-Agent Architecture (design)</a:t>
+            </a:r>
+          </a:p>
+          <a:p>
+            <a:pPr>
+              <a:defRPr sz="1300">
+                <a:solidFill>
+                  <a:srgbClr val="555555"/>
+                </a:solidFill>
+              </a:defRPr>
+            </a:pPr>
+            <a:r>
+              <a:t>Role-specialized agents coordinated by an orchestrator; net-new lever = verify/debate panel</a:t>
+            </a:r>
+          </a:p>
+        </p:txBody>
+      </p:sp>
+      <p:pic>
+        <p:nvPicPr>
+          <p:cNvPr id="3" name="Picture 2" descr="multi_agent_architecture.png"/>
+          <p:cNvPicPr>
+            <a:picLocks noChangeAspect="1"/>
+          </p:cNvPicPr>
+          <p:nvPr/>
+        </p:nvPicPr>
+        <p:blipFill>
+          <a:blip r:embed="rId2"/>
+          <a:stretch>
+            <a:fillRect/>
+          </a:stretch>
+        </p:blipFill>
+        <p:spPr>
+          <a:xfrm>
+            <a:off x="457200" y="1097280"/>
+            <a:ext cx="8229600" cy="4336622"/>
+          </a:xfrm>
+          <a:prstGeom prst="rect">
+            <a:avLst/>
+          </a:prstGeom>
+        </p:spPr>
+      </p:pic>
+      <p:sp>
+        <p:nvSpPr>
+          <p:cNvPr id="4" name="TextBox 3"/>
+          <p:cNvSpPr txBox="1"/>
+          <p:nvPr/>
+        </p:nvSpPr>
+        <p:spPr>
+          <a:xfrm>
+            <a:off x="8869680" y="1188720"/>
+            <a:ext cx="3108960" cy="5120640"/>
+          </a:xfrm>
+          <a:prstGeom prst="rect">
+            <a:avLst/>
+          </a:prstGeom>
+          <a:noFill/>
+        </p:spPr>
+        <p:txBody>
+          <a:bodyPr wrap="square">
+            <a:spAutoFit/>
+          </a:bodyPr>
+          <a:lstStyle/>
+          <a:p>
+            <a:pPr>
+              <a:spcAft>
+                <a:spcPts val="600"/>
+              </a:spcAft>
+              <a:defRPr sz="1200" b="1">
+                <a:solidFill>
+                  <a:srgbClr val="B45F06"/>
+                </a:solidFill>
+              </a:defRPr>
+            </a:pPr>
+            <a:r>
+              <a:t>• ① Orchestrator — route &amp; coordinate</a:t>
+            </a:r>
+          </a:p>
+          <a:p>
+            <a:pPr>
+              <a:spcAft>
+                <a:spcPts val="600"/>
+              </a:spcAft>
+              <a:defRPr sz="1200" b="0"/>
+            </a:pPr>
+            <a:r>
+              <a:t>• ② Evidence agents — Local-KB / Gap / Web</a:t>
+            </a:r>
+          </a:p>
+          <a:p>
+            <a:pPr>
+              <a:spcAft>
+                <a:spcPts val="600"/>
+              </a:spcAft>
+              <a:defRPr sz="1200" b="0"/>
+            </a:pPr>
+            <a:r>
+              <a:t>• ③ Judge Panel — ItV sufficiency (5 Identify + Verify)</a:t>
+            </a:r>
+          </a:p>
+          <a:p>
+            <a:pPr>
+              <a:spcAft>
+                <a:spcPts val="600"/>
+              </a:spcAft>
+              <a:defRPr sz="1200" b="0"/>
+            </a:pPr>
+            <a:r>
+              <a:t>• ④ Answer agent — frozen GPT-4</a:t>
+            </a:r>
+          </a:p>
+          <a:p>
+            <a:pPr>
+              <a:spcAft>
+                <a:spcPts val="600"/>
+              </a:spcAft>
+              <a:defRPr sz="1200" b="1">
+                <a:solidFill>
+                  <a:srgbClr val="B45F06"/>
+                </a:solidFill>
+              </a:defRPr>
+            </a:pPr>
+            <a:r>
+              <a:t>• ⑤ Debate panel — Proponent/Opponent/Judge (TF) — NEW</a:t>
+            </a:r>
+          </a:p>
+          <a:p>
+            <a:pPr>
+              <a:spcAft>
+                <a:spcPts val="600"/>
+              </a:spcAft>
+              <a:defRPr sz="1200" b="0"/>
+            </a:pPr>
+            <a:r>
+              <a:t>• ⑥ Curation agent — persist verified facts (optional)</a:t>
+            </a:r>
+          </a:p>
+          <a:p>
+            <a:pPr>
+              <a:spcAft>
+                <a:spcPts val="600"/>
+              </a:spcAft>
+              <a:defRPr sz="1200" b="0"/>
+            </a:pPr>
+          </a:p>
+          <a:p>
+            <a:pPr>
+              <a:spcAft>
+                <a:spcPts val="600"/>
+              </a:spcAft>
+              <a:defRPr sz="1200" b="0"/>
+            </a:pPr>
+            <a:r>
+              <a:t>• Only ⑤ is a net-new accuracy lever; must be A/B-tested</a:t>
+            </a:r>
+          </a:p>
+        </p:txBody>
+      </p:sp>
+    </p:spTree>
+  </p:cSld>
+  <p:clrMapOvr>
+    <a:masterClrMapping/>
+  </p:clrMapOvr>
+</p:sld>
+</file>
+
 <file path=ppt/theme/theme1.xml><?xml version="1.0" encoding="utf-8"?>
 <a:theme xmlns:a="http://schemas.openxmlformats.org/drawingml/2006/main" name="Office Theme">
   <a:themeElements>

</xml_diff>